<commit_message>
Use explicit business-resource ownership and deployment note
</commit_message>
<xml_diff>
--- a/docs/presentations/MYA_Architecture_v5_20260915.pptx
+++ b/docs/presentations/MYA_Architecture_v5_20260915.pptx
@@ -2,22 +2,22 @@
 <file path=ppt/presentation.xml><?xml version="1.0" encoding="utf-8"?>
 <p:presentation xmlns:p="http://schemas.openxmlformats.org/presentationml/2006/main">
   <p:sldMasterIdLst>
-    <p:sldMasterId xmlns:r="http://schemas.openxmlformats.org/officeDocument/2006/relationships" id="2147483648" r:id="Rcc03e25267824507"/>
+    <p:sldMasterId xmlns:r="http://schemas.openxmlformats.org/officeDocument/2006/relationships" id="2147483648" r:id="Rfc10d8027b0941bd"/>
   </p:sldMasterIdLst>
   <p:notesMasterIdLst>
-    <p:notesMasterId xmlns:r="http://schemas.openxmlformats.org/officeDocument/2006/relationships" r:id="Refbf6224a4ea4f0b"/>
+    <p:notesMasterId xmlns:r="http://schemas.openxmlformats.org/officeDocument/2006/relationships" r:id="R22e7a7692ecb49b2"/>
   </p:notesMasterIdLst>
   <p:sldIdLst>
-    <p:sldId xmlns:r="http://schemas.openxmlformats.org/officeDocument/2006/relationships" id="256" r:id="R3ed8831379764acf"/>
-    <p:sldId xmlns:r="http://schemas.openxmlformats.org/officeDocument/2006/relationships" id="257" r:id="R39ae553731fd4582"/>
-    <p:sldId xmlns:r="http://schemas.openxmlformats.org/officeDocument/2006/relationships" id="258" r:id="R0a80782f44c240df"/>
-    <p:sldId xmlns:r="http://schemas.openxmlformats.org/officeDocument/2006/relationships" id="259" r:id="R80a223c82ca04d0b"/>
-    <p:sldId xmlns:r="http://schemas.openxmlformats.org/officeDocument/2006/relationships" id="260" r:id="Rbb902a0c74e64729"/>
-    <p:sldId xmlns:r="http://schemas.openxmlformats.org/officeDocument/2006/relationships" id="261" r:id="Rdc0dacff36e34674"/>
-    <p:sldId xmlns:r="http://schemas.openxmlformats.org/officeDocument/2006/relationships" id="262" r:id="Rf41a36642c754482"/>
-    <p:sldId xmlns:r="http://schemas.openxmlformats.org/officeDocument/2006/relationships" id="263" r:id="R61714e4a9c08477d"/>
-    <p:sldId xmlns:r="http://schemas.openxmlformats.org/officeDocument/2006/relationships" id="264" r:id="Rafb07747d929460a"/>
-    <p:sldId xmlns:r="http://schemas.openxmlformats.org/officeDocument/2006/relationships" id="265" r:id="R53fc40077d6745a6"/>
+    <p:sldId xmlns:r="http://schemas.openxmlformats.org/officeDocument/2006/relationships" id="256" r:id="Rb274a916cf304ad8"/>
+    <p:sldId xmlns:r="http://schemas.openxmlformats.org/officeDocument/2006/relationships" id="257" r:id="R827228de38a4405d"/>
+    <p:sldId xmlns:r="http://schemas.openxmlformats.org/officeDocument/2006/relationships" id="258" r:id="R47b02f8096e0491a"/>
+    <p:sldId xmlns:r="http://schemas.openxmlformats.org/officeDocument/2006/relationships" id="259" r:id="Rbe8b0ddce46d42ba"/>
+    <p:sldId xmlns:r="http://schemas.openxmlformats.org/officeDocument/2006/relationships" id="260" r:id="R3ca3b0dbe822465b"/>
+    <p:sldId xmlns:r="http://schemas.openxmlformats.org/officeDocument/2006/relationships" id="261" r:id="Re4696780bf864d0f"/>
+    <p:sldId xmlns:r="http://schemas.openxmlformats.org/officeDocument/2006/relationships" id="262" r:id="Rc76b6bb69cb24f7f"/>
+    <p:sldId xmlns:r="http://schemas.openxmlformats.org/officeDocument/2006/relationships" id="263" r:id="R9cffa42d3d514167"/>
+    <p:sldId xmlns:r="http://schemas.openxmlformats.org/officeDocument/2006/relationships" id="264" r:id="R6218b324bd734bd0"/>
+    <p:sldId xmlns:r="http://schemas.openxmlformats.org/officeDocument/2006/relationships" id="265" r:id="R82385a7213974f61"/>
   </p:sldIdLst>
   <p:sldSz cx="12192000" cy="6858000"/>
   <p:notesSz cx="6858000" cy="9144000"/>
@@ -1349,7 +1349,7 @@
   </p:cSld>
   <p:clrMap bg1="lt1" tx1="dk1" bg2="lt2" tx2="dk2" accent1="accent1" accent2="accent2" accent3="accent3" accent4="accent4" accent5="accent5" accent6="accent6" hlink="hlink" folHlink="folHlink"/>
   <p:sldLayoutIdLst>
-    <p:sldLayoutId xmlns:r="http://schemas.openxmlformats.org/officeDocument/2006/relationships" id="2147483649" r:id="Rbbfa74ffed6a47c6"/>
+    <p:sldLayoutId xmlns:r="http://schemas.openxmlformats.org/officeDocument/2006/relationships" id="2147483649" r:id="Rd1f4b07935714bc6"/>
   </p:sldLayoutIdLst>
   <p:txStyles>
     <p:titleStyle>
@@ -1904,7 +1904,7 @@
           <p:nvPr/>
         </p:nvPicPr>
         <p:blipFill>
-          <a:blip xmlns:r="http://schemas.openxmlformats.org/officeDocument/2006/relationships" xmlns:a="http://schemas.openxmlformats.org/drawingml/2006/main" r:embed="Ra97c5b756b5f4ff7"/>
+          <a:blip xmlns:r="http://schemas.openxmlformats.org/officeDocument/2006/relationships" xmlns:a="http://schemas.openxmlformats.org/drawingml/2006/main" r:embed="Re12bcf3783684735"/>
           <a:stretch xmlns:a="http://schemas.openxmlformats.org/drawingml/2006/main"/>
         </p:blipFill>
         <p:spPr>
@@ -1922,7 +1922,7 @@
           <p:cNvPr id="2" name="">
             <a:extLst xmlns:a="http://schemas.openxmlformats.org/drawingml/2006/main">
               <a:ext uri="{FF2B5EF4-FFF2-40B4-BE49-F238E27FC236}">
-                <a16:creationId xmlns:a16="http://schemas.microsoft.com/office/drawing/2014/main" id="{895066BD-D994-43AB-85D5-BD3785B394F1}"/>
+                <a16:creationId xmlns:a16="http://schemas.microsoft.com/office/drawing/2014/main" id="{A97C7044-7B81-424C-8E56-48027497489B}"/>
               </a:ext>
             </a:extLst>
           </p:cNvPr>
@@ -1979,7 +1979,7 @@
           <p:cNvPr id="3" name="">
             <a:extLst xmlns:a="http://schemas.openxmlformats.org/drawingml/2006/main">
               <a:ext uri="{FF2B5EF4-FFF2-40B4-BE49-F238E27FC236}">
-                <a16:creationId xmlns:a16="http://schemas.microsoft.com/office/drawing/2014/main" id="{D2F9FEC1-B080-4C1C-9F3E-25641440CCAE}"/>
+                <a16:creationId xmlns:a16="http://schemas.microsoft.com/office/drawing/2014/main" id="{3C771A3F-A62D-46D4-B877-D9AE69C7AF78}"/>
               </a:ext>
             </a:extLst>
           </p:cNvPr>
@@ -2059,7 +2059,7 @@
           <p:cNvPr id="4" name="">
             <a:extLst xmlns:a="http://schemas.openxmlformats.org/drawingml/2006/main">
               <a:ext uri="{FF2B5EF4-FFF2-40B4-BE49-F238E27FC236}">
-                <a16:creationId xmlns:a16="http://schemas.microsoft.com/office/drawing/2014/main" id="{4B905852-463B-4827-8B67-3999061BE90D}"/>
+                <a16:creationId xmlns:a16="http://schemas.microsoft.com/office/drawing/2014/main" id="{ECCECFD5-065D-4D07-97C2-73AD85449FD8}"/>
               </a:ext>
             </a:extLst>
           </p:cNvPr>
@@ -2139,7 +2139,7 @@
           <p:cNvPr id="5" name="">
             <a:extLst xmlns:a="http://schemas.openxmlformats.org/drawingml/2006/main">
               <a:ext uri="{FF2B5EF4-FFF2-40B4-BE49-F238E27FC236}">
-                <a16:creationId xmlns:a16="http://schemas.microsoft.com/office/drawing/2014/main" id="{59EEC09A-298A-480B-9028-7364DB052846}"/>
+                <a16:creationId xmlns:a16="http://schemas.microsoft.com/office/drawing/2014/main" id="{7370D46C-675C-4434-88BE-B3A93D20D6E0}"/>
               </a:ext>
             </a:extLst>
           </p:cNvPr>
@@ -2196,7 +2196,7 @@
           <p:cNvPr id="6" name="">
             <a:extLst xmlns:a="http://schemas.openxmlformats.org/drawingml/2006/main">
               <a:ext uri="{FF2B5EF4-FFF2-40B4-BE49-F238E27FC236}">
-                <a16:creationId xmlns:a16="http://schemas.microsoft.com/office/drawing/2014/main" id="{285DE79E-F1C0-49E4-98C1-7C1A33D30826}"/>
+                <a16:creationId xmlns:a16="http://schemas.microsoft.com/office/drawing/2014/main" id="{FDB59F6A-8B50-4830-8619-B87345F546E8}"/>
               </a:ext>
             </a:extLst>
           </p:cNvPr>
@@ -2253,7 +2253,7 @@
                 <a:latin typeface="Hiragino Sans GB"/>
                 <a:ea typeface="Hiragino Sans GB"/>
                 <a:cs typeface="Hiragino Sans GB"/>
-                <a:hlinkClick xmlns:r="http://schemas.openxmlformats.org/officeDocument/2006/relationships" r:id="R6b8b02fd8ac74b3b"/>
+                <a:hlinkClick xmlns:r="http://schemas.openxmlformats.org/officeDocument/2006/relationships" r:id="R724e2b6fd6704ad8"/>
               </a:rPr>
               <a:t>MYA 实现与实测</a:t>
             </a:r>
@@ -2263,7 +2263,7 @@
     </p:spTree>
     <p:extLst>
       <p:ext uri="{BB962C8B-B14F-4D97-AF65-F5344CB8AC3E}">
-        <p14:creationId xmlns:p14="http://schemas.microsoft.com/office/powerpoint/2010/main" val="712031411"/>
+        <p14:creationId xmlns:p14="http://schemas.microsoft.com/office/powerpoint/2010/main" val="594435554"/>
       </p:ext>
     </p:extLst>
   </p:cSld>
@@ -2294,7 +2294,7 @@
           <p:cNvPr id="7" name="">
             <a:extLst xmlns:a="http://schemas.openxmlformats.org/drawingml/2006/main">
               <a:ext uri="{FF2B5EF4-FFF2-40B4-BE49-F238E27FC236}">
-                <a16:creationId xmlns:a16="http://schemas.microsoft.com/office/drawing/2014/main" id="{F53BF4F8-EB96-4321-A6AA-308183442DCB}"/>
+                <a16:creationId xmlns:a16="http://schemas.microsoft.com/office/drawing/2014/main" id="{0F0D8F38-6F0D-4B9E-99D0-70D3875333C9}"/>
               </a:ext>
             </a:extLst>
           </p:cNvPr>
@@ -2351,7 +2351,7 @@
           <p:cNvPr id="2" name="">
             <a:extLst xmlns:a="http://schemas.openxmlformats.org/drawingml/2006/main">
               <a:ext uri="{FF2B5EF4-FFF2-40B4-BE49-F238E27FC236}">
-                <a16:creationId xmlns:a16="http://schemas.microsoft.com/office/drawing/2014/main" id="{07E6278D-A205-49B4-84B1-8915FFEF1B1A}"/>
+                <a16:creationId xmlns:a16="http://schemas.microsoft.com/office/drawing/2014/main" id="{8795F0C6-7CEA-4133-950E-DE1F9F03C6C5}"/>
               </a:ext>
             </a:extLst>
           </p:cNvPr>
@@ -2408,7 +2408,7 @@
           <p:cNvPr id="3" name="">
             <a:extLst xmlns:a="http://schemas.openxmlformats.org/drawingml/2006/main">
               <a:ext uri="{FF2B5EF4-FFF2-40B4-BE49-F238E27FC236}">
-                <a16:creationId xmlns:a16="http://schemas.microsoft.com/office/drawing/2014/main" id="{373E9A44-A3FA-43DF-BA29-63C56D3EF2F8}"/>
+                <a16:creationId xmlns:a16="http://schemas.microsoft.com/office/drawing/2014/main" id="{26C5BCC0-8C1D-451B-B21C-65BF8FB920CE}"/>
               </a:ext>
             </a:extLst>
           </p:cNvPr>
@@ -2968,7 +2968,7 @@
           <p:cNvPr id="5" name="">
             <a:extLst xmlns:a="http://schemas.openxmlformats.org/drawingml/2006/main">
               <a:ext uri="{FF2B5EF4-FFF2-40B4-BE49-F238E27FC236}">
-                <a16:creationId xmlns:a16="http://schemas.microsoft.com/office/drawing/2014/main" id="{72D79AC7-EE74-4C69-9C77-FAAD681E1AEC}"/>
+                <a16:creationId xmlns:a16="http://schemas.microsoft.com/office/drawing/2014/main" id="{092BF57B-DEE7-40E1-A301-DA33876DD999}"/>
               </a:ext>
             </a:extLst>
           </p:cNvPr>
@@ -3025,7 +3025,7 @@
           <p:cNvPr id="6" name="">
             <a:extLst xmlns:a="http://schemas.openxmlformats.org/drawingml/2006/main">
               <a:ext uri="{FF2B5EF4-FFF2-40B4-BE49-F238E27FC236}">
-                <a16:creationId xmlns:a16="http://schemas.microsoft.com/office/drawing/2014/main" id="{D1D5AF43-9909-4EB5-B7EC-565CA660B19E}"/>
+                <a16:creationId xmlns:a16="http://schemas.microsoft.com/office/drawing/2014/main" id="{E7264E4C-8BAA-4E5F-A92D-0FA7DB1155EE}"/>
               </a:ext>
             </a:extLst>
           </p:cNvPr>
@@ -3082,7 +3082,7 @@
                 <a:latin typeface="Hiragino Sans GB"/>
                 <a:ea typeface="Hiragino Sans GB"/>
                 <a:cs typeface="Hiragino Sans GB"/>
-                <a:hlinkClick xmlns:r="http://schemas.openxmlformats.org/officeDocument/2006/relationships" r:id="R101cd69c4f4a4867"/>
+                <a:hlinkClick xmlns:r="http://schemas.openxmlformats.org/officeDocument/2006/relationships" r:id="R3ff26ea71a244e9e"/>
               </a:rPr>
               <a:t>MYA 实现与实测</a:t>
             </a:r>
@@ -3092,7 +3092,7 @@
     </p:spTree>
     <p:extLst>
       <p:ext uri="{BB962C8B-B14F-4D97-AF65-F5344CB8AC3E}">
-        <p14:creationId xmlns:p14="http://schemas.microsoft.com/office/powerpoint/2010/main" val="1118524742"/>
+        <p14:creationId xmlns:p14="http://schemas.microsoft.com/office/powerpoint/2010/main" val="1308189478"/>
       </p:ext>
     </p:extLst>
   </p:cSld>
@@ -3123,7 +3123,7 @@
           <p:cNvPr id="36" name="">
             <a:extLst xmlns:a="http://schemas.openxmlformats.org/drawingml/2006/main">
               <a:ext uri="{FF2B5EF4-FFF2-40B4-BE49-F238E27FC236}">
-                <a16:creationId xmlns:a16="http://schemas.microsoft.com/office/drawing/2014/main" id="{E2985E9A-6CB6-4E56-819A-D29D5C9D7C6E}"/>
+                <a16:creationId xmlns:a16="http://schemas.microsoft.com/office/drawing/2014/main" id="{9DEB391C-270B-475E-8F7D-DB2849029D38}"/>
               </a:ext>
             </a:extLst>
           </p:cNvPr>
@@ -3180,7 +3180,7 @@
           <p:cNvPr id="2" name="">
             <a:extLst xmlns:a="http://schemas.openxmlformats.org/drawingml/2006/main">
               <a:ext uri="{FF2B5EF4-FFF2-40B4-BE49-F238E27FC236}">
-                <a16:creationId xmlns:a16="http://schemas.microsoft.com/office/drawing/2014/main" id="{80B7EAC7-8FD1-47B0-A365-4039B0855792}"/>
+                <a16:creationId xmlns:a16="http://schemas.microsoft.com/office/drawing/2014/main" id="{02155CD3-6D3F-4EC2-85D5-86467AC2E47A}"/>
               </a:ext>
             </a:extLst>
           </p:cNvPr>
@@ -3227,7 +3227,7 @@
                 <a:ea typeface="Hiragino Sans GB"/>
                 <a:cs typeface="Hiragino Sans GB"/>
               </a:rPr>
-              <a:t>MYA 连接用户与 Agent；业务资源方保留验证策略和执行权</a:t>
+              <a:t>MYA 提供可验证的用户授权，业务系统掌握执行权。</a:t>
             </a:r>
           </a:p>
         </p:txBody>
@@ -3237,7 +3237,7 @@
           <p:cNvPr id="3" name="">
             <a:extLst xmlns:a="http://schemas.openxmlformats.org/drawingml/2006/main">
               <a:ext uri="{FF2B5EF4-FFF2-40B4-BE49-F238E27FC236}">
-                <a16:creationId xmlns:a16="http://schemas.microsoft.com/office/drawing/2014/main" id="{7F045C52-1FF8-4A6E-85BA-368EA0226072}"/>
+                <a16:creationId xmlns:a16="http://schemas.microsoft.com/office/drawing/2014/main" id="{28B63E2E-E976-473E-B6FC-21F093565F37}"/>
               </a:ext>
             </a:extLst>
           </p:cNvPr>
@@ -3294,7 +3294,7 @@
           <p:cNvPr id="4" name="">
             <a:extLst xmlns:a="http://schemas.openxmlformats.org/drawingml/2006/main">
               <a:ext uri="{FF2B5EF4-FFF2-40B4-BE49-F238E27FC236}">
-                <a16:creationId xmlns:a16="http://schemas.microsoft.com/office/drawing/2014/main" id="{81AB9DF4-225D-42F0-B4DE-1728E79C39E5}"/>
+                <a16:creationId xmlns:a16="http://schemas.microsoft.com/office/drawing/2014/main" id="{2FE7BDA6-52BA-4A3A-81C6-37BB7B1A904F}"/>
               </a:ext>
             </a:extLst>
           </p:cNvPr>
@@ -3325,7 +3325,7 @@
           <p:cNvPr id="5" name="">
             <a:extLst xmlns:a="http://schemas.openxmlformats.org/drawingml/2006/main">
               <a:ext uri="{FF2B5EF4-FFF2-40B4-BE49-F238E27FC236}">
-                <a16:creationId xmlns:a16="http://schemas.microsoft.com/office/drawing/2014/main" id="{F7FBDA08-2EEE-4126-B684-438EBC7BA48B}"/>
+                <a16:creationId xmlns:a16="http://schemas.microsoft.com/office/drawing/2014/main" id="{CE932D85-8001-4A77-B53E-DBD931A4A1D4}"/>
               </a:ext>
             </a:extLst>
           </p:cNvPr>
@@ -3382,7 +3382,7 @@
           <p:cNvPr id="6" name="">
             <a:extLst xmlns:a="http://schemas.openxmlformats.org/drawingml/2006/main">
               <a:ext uri="{FF2B5EF4-FFF2-40B4-BE49-F238E27FC236}">
-                <a16:creationId xmlns:a16="http://schemas.microsoft.com/office/drawing/2014/main" id="{34A1BFA4-D27C-4DED-B851-D399F3B8EEC8}"/>
+                <a16:creationId xmlns:a16="http://schemas.microsoft.com/office/drawing/2014/main" id="{5C023261-A082-4B22-A510-29A8B5EFBB26}"/>
               </a:ext>
             </a:extLst>
           </p:cNvPr>
@@ -3413,7 +3413,7 @@
           <p:cNvPr id="7" name="">
             <a:extLst xmlns:a="http://schemas.openxmlformats.org/drawingml/2006/main">
               <a:ext uri="{FF2B5EF4-FFF2-40B4-BE49-F238E27FC236}">
-                <a16:creationId xmlns:a16="http://schemas.microsoft.com/office/drawing/2014/main" id="{BD46E3F0-C511-4195-8F6A-DEDEB3B34969}"/>
+                <a16:creationId xmlns:a16="http://schemas.microsoft.com/office/drawing/2014/main" id="{47B2D0FB-D84C-48DA-81BF-5B2E3B8171B3}"/>
               </a:ext>
             </a:extLst>
           </p:cNvPr>
@@ -3470,7 +3470,7 @@
           <p:cNvPr id="8" name="">
             <a:extLst xmlns:a="http://schemas.openxmlformats.org/drawingml/2006/main">
               <a:ext uri="{FF2B5EF4-FFF2-40B4-BE49-F238E27FC236}">
-                <a16:creationId xmlns:a16="http://schemas.microsoft.com/office/drawing/2014/main" id="{DA07A03A-5FB5-4F96-9DC5-16A4A6D6D789}"/>
+                <a16:creationId xmlns:a16="http://schemas.microsoft.com/office/drawing/2014/main" id="{82ACD2F0-CF58-48B6-8A04-6EFCEA11059B}"/>
               </a:ext>
             </a:extLst>
           </p:cNvPr>
@@ -3501,7 +3501,7 @@
           <p:cNvPr id="9" name="">
             <a:extLst xmlns:a="http://schemas.openxmlformats.org/drawingml/2006/main">
               <a:ext uri="{FF2B5EF4-FFF2-40B4-BE49-F238E27FC236}">
-                <a16:creationId xmlns:a16="http://schemas.microsoft.com/office/drawing/2014/main" id="{883FF80B-4C71-49D3-9637-D7A207FFF98E}"/>
+                <a16:creationId xmlns:a16="http://schemas.microsoft.com/office/drawing/2014/main" id="{FBA9F665-391A-486C-A19E-D32034348564}"/>
               </a:ext>
             </a:extLst>
           </p:cNvPr>
@@ -3558,7 +3558,7 @@
           <p:cNvPr id="10" name="">
             <a:extLst xmlns:a="http://schemas.openxmlformats.org/drawingml/2006/main">
               <a:ext uri="{FF2B5EF4-FFF2-40B4-BE49-F238E27FC236}">
-                <a16:creationId xmlns:a16="http://schemas.microsoft.com/office/drawing/2014/main" id="{7D90081A-1002-4CF5-BF01-8FF088FD5E65}"/>
+                <a16:creationId xmlns:a16="http://schemas.microsoft.com/office/drawing/2014/main" id="{D23103B4-E338-45E4-A49B-9AA68357DEDD}"/>
               </a:ext>
             </a:extLst>
           </p:cNvPr>
@@ -3589,7 +3589,7 @@
           <p:cNvPr id="11" name="">
             <a:extLst xmlns:a="http://schemas.openxmlformats.org/drawingml/2006/main">
               <a:ext uri="{FF2B5EF4-FFF2-40B4-BE49-F238E27FC236}">
-                <a16:creationId xmlns:a16="http://schemas.microsoft.com/office/drawing/2014/main" id="{DE25A1C3-25C3-4405-8E59-AF3F90A2D1AF}"/>
+                <a16:creationId xmlns:a16="http://schemas.microsoft.com/office/drawing/2014/main" id="{7E21078D-B2B7-49F6-A353-03461B28BBB6}"/>
               </a:ext>
             </a:extLst>
           </p:cNvPr>
@@ -3646,7 +3646,7 @@
           <p:cNvPr id="12" name="">
             <a:extLst xmlns:a="http://schemas.openxmlformats.org/drawingml/2006/main">
               <a:ext uri="{FF2B5EF4-FFF2-40B4-BE49-F238E27FC236}">
-                <a16:creationId xmlns:a16="http://schemas.microsoft.com/office/drawing/2014/main" id="{6891ECA6-E074-4755-8075-2E1F2DA2A80A}"/>
+                <a16:creationId xmlns:a16="http://schemas.microsoft.com/office/drawing/2014/main" id="{3362DD40-F973-4E1E-BA7D-4A5784767F90}"/>
               </a:ext>
             </a:extLst>
           </p:cNvPr>
@@ -3679,7 +3679,7 @@
           <p:cNvPr id="13" name="">
             <a:extLst xmlns:a="http://schemas.openxmlformats.org/drawingml/2006/main">
               <a:ext uri="{FF2B5EF4-FFF2-40B4-BE49-F238E27FC236}">
-                <a16:creationId xmlns:a16="http://schemas.microsoft.com/office/drawing/2014/main" id="{ACED5AA1-506F-4545-A57C-542942BDA23F}"/>
+                <a16:creationId xmlns:a16="http://schemas.microsoft.com/office/drawing/2014/main" id="{510E91A5-127B-4AF2-B15F-E13A700B66C3}"/>
               </a:ext>
             </a:extLst>
           </p:cNvPr>
@@ -3736,7 +3736,7 @@
           <p:cNvPr id="14" name="">
             <a:extLst xmlns:a="http://schemas.openxmlformats.org/drawingml/2006/main">
               <a:ext uri="{FF2B5EF4-FFF2-40B4-BE49-F238E27FC236}">
-                <a16:creationId xmlns:a16="http://schemas.microsoft.com/office/drawing/2014/main" id="{929D9802-2B65-487C-AB4F-46F826D5E30F}"/>
+                <a16:creationId xmlns:a16="http://schemas.microsoft.com/office/drawing/2014/main" id="{AE83B25C-89E3-46D3-81C5-8E099BFD22FE}"/>
               </a:ext>
             </a:extLst>
           </p:cNvPr>
@@ -3793,7 +3793,7 @@
           <p:cNvPr id="15" name="">
             <a:extLst xmlns:a="http://schemas.openxmlformats.org/drawingml/2006/main">
               <a:ext uri="{FF2B5EF4-FFF2-40B4-BE49-F238E27FC236}">
-                <a16:creationId xmlns:a16="http://schemas.microsoft.com/office/drawing/2014/main" id="{A0EE4217-9F8B-45AC-8334-0788EF82EF6F}"/>
+                <a16:creationId xmlns:a16="http://schemas.microsoft.com/office/drawing/2014/main" id="{D16DEF6B-17EA-4784-B0C6-2BA54A94EC4E}"/>
               </a:ext>
             </a:extLst>
           </p:cNvPr>
@@ -3826,7 +3826,7 @@
           <p:cNvPr id="16" name="">
             <a:extLst xmlns:a="http://schemas.openxmlformats.org/drawingml/2006/main">
               <a:ext uri="{FF2B5EF4-FFF2-40B4-BE49-F238E27FC236}">
-                <a16:creationId xmlns:a16="http://schemas.microsoft.com/office/drawing/2014/main" id="{39B2C7FB-6D75-44DA-9FCC-3A8A09CA6144}"/>
+                <a16:creationId xmlns:a16="http://schemas.microsoft.com/office/drawing/2014/main" id="{21E99486-1961-4F99-A4DE-893643B0106A}"/>
               </a:ext>
             </a:extLst>
           </p:cNvPr>
@@ -3883,7 +3883,7 @@
           <p:cNvPr id="17" name="">
             <a:extLst xmlns:a="http://schemas.openxmlformats.org/drawingml/2006/main">
               <a:ext uri="{FF2B5EF4-FFF2-40B4-BE49-F238E27FC236}">
-                <a16:creationId xmlns:a16="http://schemas.microsoft.com/office/drawing/2014/main" id="{21CB1234-54D7-4E23-86F7-E4E5DC74248A}"/>
+                <a16:creationId xmlns:a16="http://schemas.microsoft.com/office/drawing/2014/main" id="{998C9E59-808A-4A3D-8309-E3DAC9758012}"/>
               </a:ext>
             </a:extLst>
           </p:cNvPr>
@@ -3940,7 +3940,7 @@
           <p:cNvPr id="18" name="">
             <a:extLst xmlns:a="http://schemas.openxmlformats.org/drawingml/2006/main">
               <a:ext uri="{FF2B5EF4-FFF2-40B4-BE49-F238E27FC236}">
-                <a16:creationId xmlns:a16="http://schemas.microsoft.com/office/drawing/2014/main" id="{79E408B5-8F09-4F75-916D-2301A6EDEF53}"/>
+                <a16:creationId xmlns:a16="http://schemas.microsoft.com/office/drawing/2014/main" id="{E4D1D94E-0602-4AA1-9CA6-0D1E2D39FC12}"/>
               </a:ext>
             </a:extLst>
           </p:cNvPr>
@@ -3973,7 +3973,7 @@
           <p:cNvPr id="19" name="">
             <a:extLst xmlns:a="http://schemas.openxmlformats.org/drawingml/2006/main">
               <a:ext uri="{FF2B5EF4-FFF2-40B4-BE49-F238E27FC236}">
-                <a16:creationId xmlns:a16="http://schemas.microsoft.com/office/drawing/2014/main" id="{0534BDEE-C6E4-40A8-A45A-BA95EC35E950}"/>
+                <a16:creationId xmlns:a16="http://schemas.microsoft.com/office/drawing/2014/main" id="{74381EF1-9AD7-4A04-80EA-F41D9D093E13}"/>
               </a:ext>
             </a:extLst>
           </p:cNvPr>
@@ -4030,7 +4030,7 @@
           <p:cNvPr id="20" name="">
             <a:extLst xmlns:a="http://schemas.openxmlformats.org/drawingml/2006/main">
               <a:ext uri="{FF2B5EF4-FFF2-40B4-BE49-F238E27FC236}">
-                <a16:creationId xmlns:a16="http://schemas.microsoft.com/office/drawing/2014/main" id="{8B2CC322-2EFC-483C-8B59-A04BA8FA83B4}"/>
+                <a16:creationId xmlns:a16="http://schemas.microsoft.com/office/drawing/2014/main" id="{97FA2D7C-CBFC-4E5E-ABCD-919603FD3486}"/>
               </a:ext>
             </a:extLst>
           </p:cNvPr>
@@ -4087,7 +4087,7 @@
           <p:cNvPr id="21" name="">
             <a:extLst xmlns:a="http://schemas.openxmlformats.org/drawingml/2006/main">
               <a:ext uri="{FF2B5EF4-FFF2-40B4-BE49-F238E27FC236}">
-                <a16:creationId xmlns:a16="http://schemas.microsoft.com/office/drawing/2014/main" id="{330C9904-3373-4DE8-9031-2FC8395C7923}"/>
+                <a16:creationId xmlns:a16="http://schemas.microsoft.com/office/drawing/2014/main" id="{4CAB5211-058E-4AA6-A6D8-7F551A5EF64C}"/>
               </a:ext>
             </a:extLst>
           </p:cNvPr>
@@ -4120,7 +4120,7 @@
           <p:cNvPr id="22" name="">
             <a:extLst xmlns:a="http://schemas.openxmlformats.org/drawingml/2006/main">
               <a:ext uri="{FF2B5EF4-FFF2-40B4-BE49-F238E27FC236}">
-                <a16:creationId xmlns:a16="http://schemas.microsoft.com/office/drawing/2014/main" id="{BEC59C42-5F05-49F0-9D6C-CA71B0B4D8A2}"/>
+                <a16:creationId xmlns:a16="http://schemas.microsoft.com/office/drawing/2014/main" id="{631EC9F4-26BB-435D-B565-91552260D45C}"/>
               </a:ext>
             </a:extLst>
           </p:cNvPr>
@@ -4177,7 +4177,7 @@
           <p:cNvPr id="23" name="">
             <a:extLst xmlns:a="http://schemas.openxmlformats.org/drawingml/2006/main">
               <a:ext uri="{FF2B5EF4-FFF2-40B4-BE49-F238E27FC236}">
-                <a16:creationId xmlns:a16="http://schemas.microsoft.com/office/drawing/2014/main" id="{9291303A-334A-4963-AB4F-E3E6AC0310AC}"/>
+                <a16:creationId xmlns:a16="http://schemas.microsoft.com/office/drawing/2014/main" id="{10BCFC00-0754-407E-BCBF-B1242B15EB04}"/>
               </a:ext>
             </a:extLst>
           </p:cNvPr>
@@ -4234,7 +4234,7 @@
           <p:cNvPr id="24" name="">
             <a:extLst xmlns:a="http://schemas.openxmlformats.org/drawingml/2006/main">
               <a:ext uri="{FF2B5EF4-FFF2-40B4-BE49-F238E27FC236}">
-                <a16:creationId xmlns:a16="http://schemas.microsoft.com/office/drawing/2014/main" id="{EB406206-F2BE-4D00-913F-66CAAC9A144C}"/>
+                <a16:creationId xmlns:a16="http://schemas.microsoft.com/office/drawing/2014/main" id="{3CAFDF84-8B60-4FB2-A5FD-8DCDBD69ABDE}"/>
               </a:ext>
             </a:extLst>
           </p:cNvPr>
@@ -4267,7 +4267,7 @@
           <p:cNvPr id="25" name="">
             <a:extLst xmlns:a="http://schemas.openxmlformats.org/drawingml/2006/main">
               <a:ext uri="{FF2B5EF4-FFF2-40B4-BE49-F238E27FC236}">
-                <a16:creationId xmlns:a16="http://schemas.microsoft.com/office/drawing/2014/main" id="{10A7ECF2-F51A-43FE-A6C1-3D1981DA46F3}"/>
+                <a16:creationId xmlns:a16="http://schemas.microsoft.com/office/drawing/2014/main" id="{5A0B2910-ED59-43FB-BA18-D0768C44148B}"/>
               </a:ext>
             </a:extLst>
           </p:cNvPr>
@@ -4324,7 +4324,7 @@
           <p:cNvPr id="26" name="">
             <a:extLst xmlns:a="http://schemas.openxmlformats.org/drawingml/2006/main">
               <a:ext uri="{FF2B5EF4-FFF2-40B4-BE49-F238E27FC236}">
-                <a16:creationId xmlns:a16="http://schemas.microsoft.com/office/drawing/2014/main" id="{D99F2F14-E6B5-40F1-9D4D-19EF9CE6A610}"/>
+                <a16:creationId xmlns:a16="http://schemas.microsoft.com/office/drawing/2014/main" id="{E489B429-52BD-4D70-8A37-7EFC35F9EEF7}"/>
               </a:ext>
             </a:extLst>
           </p:cNvPr>
@@ -4489,7 +4489,7 @@
           <p:cNvPr id="31" name="">
             <a:extLst xmlns:a="http://schemas.openxmlformats.org/drawingml/2006/main">
               <a:ext uri="{FF2B5EF4-FFF2-40B4-BE49-F238E27FC236}">
-                <a16:creationId xmlns:a16="http://schemas.microsoft.com/office/drawing/2014/main" id="{8DED3099-F0A0-4CBB-80C5-51A500BA4CAE}"/>
+                <a16:creationId xmlns:a16="http://schemas.microsoft.com/office/drawing/2014/main" id="{AEB9C2E2-FE7F-4B60-B81F-3A351CA3DD66}"/>
               </a:ext>
             </a:extLst>
           </p:cNvPr>
@@ -4546,7 +4546,7 @@
           <p:cNvPr id="32" name="">
             <a:extLst xmlns:a="http://schemas.openxmlformats.org/drawingml/2006/main">
               <a:ext uri="{FF2B5EF4-FFF2-40B4-BE49-F238E27FC236}">
-                <a16:creationId xmlns:a16="http://schemas.microsoft.com/office/drawing/2014/main" id="{8141B753-132D-41CF-81A2-F19F477401CA}"/>
+                <a16:creationId xmlns:a16="http://schemas.microsoft.com/office/drawing/2014/main" id="{8C6FD3D2-7752-4BCF-9DD1-484DAE2C2F23}"/>
               </a:ext>
             </a:extLst>
           </p:cNvPr>
@@ -4603,7 +4603,7 @@
           <p:cNvPr id="33" name="">
             <a:extLst xmlns:a="http://schemas.openxmlformats.org/drawingml/2006/main">
               <a:ext uri="{FF2B5EF4-FFF2-40B4-BE49-F238E27FC236}">
-                <a16:creationId xmlns:a16="http://schemas.microsoft.com/office/drawing/2014/main" id="{3D0786E7-5B27-4E95-ABD8-6043EA79E6F8}"/>
+                <a16:creationId xmlns:a16="http://schemas.microsoft.com/office/drawing/2014/main" id="{702505B8-6D29-4BDC-9EB7-379928F36452}"/>
               </a:ext>
             </a:extLst>
           </p:cNvPr>
@@ -4660,19 +4660,19 @@
           <p:cNvPr id="34" name="">
             <a:extLst xmlns:a="http://schemas.openxmlformats.org/drawingml/2006/main">
               <a:ext uri="{FF2B5EF4-FFF2-40B4-BE49-F238E27FC236}">
-                <a16:creationId xmlns:a16="http://schemas.microsoft.com/office/drawing/2014/main" id="{35F84D5D-AA4B-42D4-B950-8D39AC815801}"/>
-              </a:ext>
-            </a:extLst>
-          </p:cNvPr>
-          <p:cNvSpPr>
-            <a:spLocks xmlns:a="http://schemas.openxmlformats.org/drawingml/2006/main" noGrp="1"/>
-          </p:cNvSpPr>
-          <p:nvPr/>
-        </p:nvSpPr>
-        <p:spPr>
-          <a:xfrm xmlns:a="http://schemas.openxmlformats.org/drawingml/2006/main">
-            <a:off x="628650" y="5981700"/>
-            <a:ext cx="10572750" cy="314325"/>
+                <a16:creationId xmlns:a16="http://schemas.microsoft.com/office/drawing/2014/main" id="{DF144612-CE98-4178-BFBF-CB45960364BE}"/>
+              </a:ext>
+            </a:extLst>
+          </p:cNvPr>
+          <p:cNvSpPr>
+            <a:spLocks xmlns:a="http://schemas.openxmlformats.org/drawingml/2006/main" noGrp="1"/>
+          </p:cNvSpPr>
+          <p:nvPr/>
+        </p:nvSpPr>
+        <p:spPr>
+          <a:xfrm xmlns:a="http://schemas.openxmlformats.org/drawingml/2006/main">
+            <a:off x="628650" y="5857875"/>
+            <a:ext cx="10906125" cy="485775"/>
           </a:xfrm>
           <a:prstGeom xmlns:a="http://schemas.openxmlformats.org/drawingml/2006/main" prst="rect">
             <a:avLst/>
@@ -4689,7 +4689,7 @@
           <a:lstStyle xmlns:a="http://schemas.openxmlformats.org/drawingml/2006/main"/>
           <a:p xmlns:a="http://schemas.openxmlformats.org/drawingml/2006/main">
             <a:pPr>
-              <a:defRPr sz="1500" b="0">
+              <a:defRPr sz="1425" b="0">
                 <a:solidFill>
                   <a:srgbClr val="60736B"/>
                 </a:solidFill>
@@ -4699,7 +4699,7 @@
               </a:defRPr>
             </a:pPr>
             <a:r>
-              <a:rPr sz="1500" b="0">
+              <a:rPr sz="1425" b="0">
                 <a:solidFill>
                   <a:srgbClr val="60736B"/>
                 </a:solidFill>
@@ -4707,7 +4707,7 @@
                 <a:ea typeface="Hiragino Sans GB"/>
                 <a:cs typeface="Hiragino Sans GB"/>
               </a:rPr>
-              <a:t>当前 Demo 同机部署在 Oracle，仅为演示方便；正式架构不要求业务交给 MYA 平台执行。</a:t>
+              <a:t>当前 Demo 为便于演示，将业务资源模拟器与 MYA 服务同机部署在 Oracle；正式接入时，业务资源由相应业务方控制。</a:t>
             </a:r>
           </a:p>
         </p:txBody>
@@ -4717,7 +4717,7 @@
           <p:cNvPr id="35" name="">
             <a:extLst xmlns:a="http://schemas.openxmlformats.org/drawingml/2006/main">
               <a:ext uri="{FF2B5EF4-FFF2-40B4-BE49-F238E27FC236}">
-                <a16:creationId xmlns:a16="http://schemas.microsoft.com/office/drawing/2014/main" id="{241B8404-8280-4516-98EE-F527CE71F921}"/>
+                <a16:creationId xmlns:a16="http://schemas.microsoft.com/office/drawing/2014/main" id="{353A4118-FE98-4CB5-B26F-D51E2B74B3FC}"/>
               </a:ext>
             </a:extLst>
           </p:cNvPr>
@@ -4774,7 +4774,7 @@
                 <a:latin typeface="Hiragino Sans GB"/>
                 <a:ea typeface="Hiragino Sans GB"/>
                 <a:cs typeface="Hiragino Sans GB"/>
-                <a:hlinkClick xmlns:r="http://schemas.openxmlformats.org/officeDocument/2006/relationships" r:id="R61d8edf7ec9f4880"/>
+                <a:hlinkClick xmlns:r="http://schemas.openxmlformats.org/officeDocument/2006/relationships" r:id="Re23330224acd4455"/>
               </a:rPr>
               <a:t>MYA 实现与实测</a:t>
             </a:r>
@@ -4784,7 +4784,7 @@
     </p:spTree>
     <p:extLst>
       <p:ext uri="{BB962C8B-B14F-4D97-AF65-F5344CB8AC3E}">
-        <p14:creationId xmlns:p14="http://schemas.microsoft.com/office/powerpoint/2010/main" val="1472331983"/>
+        <p14:creationId xmlns:p14="http://schemas.microsoft.com/office/powerpoint/2010/main" val="1605144521"/>
       </p:ext>
     </p:extLst>
   </p:cSld>
@@ -4815,7 +4815,7 @@
           <p:cNvPr id="46" name="">
             <a:extLst xmlns:a="http://schemas.openxmlformats.org/drawingml/2006/main">
               <a:ext uri="{FF2B5EF4-FFF2-40B4-BE49-F238E27FC236}">
-                <a16:creationId xmlns:a16="http://schemas.microsoft.com/office/drawing/2014/main" id="{6B023C23-AB19-4E5F-86FA-228863040776}"/>
+                <a16:creationId xmlns:a16="http://schemas.microsoft.com/office/drawing/2014/main" id="{558B9CFE-C596-44A1-9B57-8DA1A0D97E7D}"/>
               </a:ext>
             </a:extLst>
           </p:cNvPr>
@@ -4872,7 +4872,7 @@
           <p:cNvPr id="2" name="">
             <a:extLst xmlns:a="http://schemas.openxmlformats.org/drawingml/2006/main">
               <a:ext uri="{FF2B5EF4-FFF2-40B4-BE49-F238E27FC236}">
-                <a16:creationId xmlns:a16="http://schemas.microsoft.com/office/drawing/2014/main" id="{21A34BC6-5481-4944-AFA3-9796D5135655}"/>
+                <a16:creationId xmlns:a16="http://schemas.microsoft.com/office/drawing/2014/main" id="{72FC1440-2091-489B-8109-4B887FF98230}"/>
               </a:ext>
             </a:extLst>
           </p:cNvPr>
@@ -4929,7 +4929,7 @@
           <p:cNvPr id="3" name="">
             <a:extLst xmlns:a="http://schemas.openxmlformats.org/drawingml/2006/main">
               <a:ext uri="{FF2B5EF4-FFF2-40B4-BE49-F238E27FC236}">
-                <a16:creationId xmlns:a16="http://schemas.microsoft.com/office/drawing/2014/main" id="{331F0FEF-D344-41CD-A430-C5037E03AD9C}"/>
+                <a16:creationId xmlns:a16="http://schemas.microsoft.com/office/drawing/2014/main" id="{7646DDCE-1F8B-4CD2-A415-F87877649FDF}"/>
               </a:ext>
             </a:extLst>
           </p:cNvPr>
@@ -4986,7 +4986,7 @@
           <p:cNvPr id="4" name="">
             <a:extLst xmlns:a="http://schemas.openxmlformats.org/drawingml/2006/main">
               <a:ext uri="{FF2B5EF4-FFF2-40B4-BE49-F238E27FC236}">
-                <a16:creationId xmlns:a16="http://schemas.microsoft.com/office/drawing/2014/main" id="{FF8B18BE-DBAF-47BC-8073-33AC7967B055}"/>
+                <a16:creationId xmlns:a16="http://schemas.microsoft.com/office/drawing/2014/main" id="{CB1BBAB8-3C7B-4327-AAB8-3D996B625CA8}"/>
               </a:ext>
             </a:extLst>
           </p:cNvPr>
@@ -5043,7 +5043,7 @@
           <p:cNvPr id="5" name="">
             <a:extLst xmlns:a="http://schemas.openxmlformats.org/drawingml/2006/main">
               <a:ext uri="{FF2B5EF4-FFF2-40B4-BE49-F238E27FC236}">
-                <a16:creationId xmlns:a16="http://schemas.microsoft.com/office/drawing/2014/main" id="{09E865D6-8DFA-4129-9F0E-EFEDA02BC326}"/>
+                <a16:creationId xmlns:a16="http://schemas.microsoft.com/office/drawing/2014/main" id="{46D2B4B6-8923-4A9B-8107-99EBB061EA52}"/>
               </a:ext>
             </a:extLst>
           </p:cNvPr>
@@ -5071,7 +5071,7 @@
           <p:cNvPr id="6" name="">
             <a:extLst xmlns:a="http://schemas.openxmlformats.org/drawingml/2006/main">
               <a:ext uri="{FF2B5EF4-FFF2-40B4-BE49-F238E27FC236}">
-                <a16:creationId xmlns:a16="http://schemas.microsoft.com/office/drawing/2014/main" id="{A4633185-0282-469E-9C9B-BF80BB99AAA0}"/>
+                <a16:creationId xmlns:a16="http://schemas.microsoft.com/office/drawing/2014/main" id="{382AB181-8990-45CD-8BD3-C82EE11FBB9B}"/>
               </a:ext>
             </a:extLst>
           </p:cNvPr>
@@ -5126,7 +5126,7 @@
           <p:cNvPr id="8" name="">
             <a:extLst xmlns:a="http://schemas.openxmlformats.org/drawingml/2006/main">
               <a:ext uri="{FF2B5EF4-FFF2-40B4-BE49-F238E27FC236}">
-                <a16:creationId xmlns:a16="http://schemas.microsoft.com/office/drawing/2014/main" id="{AAB26DDA-5BE3-462C-B455-50BC274906BD}"/>
+                <a16:creationId xmlns:a16="http://schemas.microsoft.com/office/drawing/2014/main" id="{F7A05871-A517-4AE3-8B37-4E4D479D6BB7}"/>
               </a:ext>
             </a:extLst>
           </p:cNvPr>
@@ -5183,7 +5183,7 @@
           <p:cNvPr id="9" name="">
             <a:extLst xmlns:a="http://schemas.openxmlformats.org/drawingml/2006/main">
               <a:ext uri="{FF2B5EF4-FFF2-40B4-BE49-F238E27FC236}">
-                <a16:creationId xmlns:a16="http://schemas.microsoft.com/office/drawing/2014/main" id="{1B7E191E-3D2A-4FC9-B806-E563E2E77031}"/>
+                <a16:creationId xmlns:a16="http://schemas.microsoft.com/office/drawing/2014/main" id="{3608419E-FF4E-4089-8761-5E4DD5C933BA}"/>
               </a:ext>
             </a:extLst>
           </p:cNvPr>
@@ -5211,7 +5211,7 @@
           <p:cNvPr id="10" name="">
             <a:extLst xmlns:a="http://schemas.openxmlformats.org/drawingml/2006/main">
               <a:ext uri="{FF2B5EF4-FFF2-40B4-BE49-F238E27FC236}">
-                <a16:creationId xmlns:a16="http://schemas.microsoft.com/office/drawing/2014/main" id="{3B705E12-CD4C-402E-9609-4DBA876E60EA}"/>
+                <a16:creationId xmlns:a16="http://schemas.microsoft.com/office/drawing/2014/main" id="{E9200D33-1D2F-48E8-8C8F-027E4036A57E}"/>
               </a:ext>
             </a:extLst>
           </p:cNvPr>
@@ -5266,7 +5266,7 @@
           <p:cNvPr id="12" name="">
             <a:extLst xmlns:a="http://schemas.openxmlformats.org/drawingml/2006/main">
               <a:ext uri="{FF2B5EF4-FFF2-40B4-BE49-F238E27FC236}">
-                <a16:creationId xmlns:a16="http://schemas.microsoft.com/office/drawing/2014/main" id="{C70C88C5-E97B-4F5B-9A8A-8B806A163A60}"/>
+                <a16:creationId xmlns:a16="http://schemas.microsoft.com/office/drawing/2014/main" id="{0EC00714-87E8-433F-96E8-F099993E1AFC}"/>
               </a:ext>
             </a:extLst>
           </p:cNvPr>
@@ -5323,7 +5323,7 @@
           <p:cNvPr id="13" name="">
             <a:extLst xmlns:a="http://schemas.openxmlformats.org/drawingml/2006/main">
               <a:ext uri="{FF2B5EF4-FFF2-40B4-BE49-F238E27FC236}">
-                <a16:creationId xmlns:a16="http://schemas.microsoft.com/office/drawing/2014/main" id="{E1EF4244-341C-4770-8329-C40C52453209}"/>
+                <a16:creationId xmlns:a16="http://schemas.microsoft.com/office/drawing/2014/main" id="{26E15BA6-B34F-4604-B67B-F65FDA7ACB0D}"/>
               </a:ext>
             </a:extLst>
           </p:cNvPr>
@@ -5351,7 +5351,7 @@
           <p:cNvPr id="14" name="">
             <a:extLst xmlns:a="http://schemas.openxmlformats.org/drawingml/2006/main">
               <a:ext uri="{FF2B5EF4-FFF2-40B4-BE49-F238E27FC236}">
-                <a16:creationId xmlns:a16="http://schemas.microsoft.com/office/drawing/2014/main" id="{F5A2D653-DEF3-41E1-B550-18601575186E}"/>
+                <a16:creationId xmlns:a16="http://schemas.microsoft.com/office/drawing/2014/main" id="{1FDE377B-1092-4508-802E-D65CB4AEA7EF}"/>
               </a:ext>
             </a:extLst>
           </p:cNvPr>
@@ -5406,7 +5406,7 @@
           <p:cNvPr id="16" name="">
             <a:extLst xmlns:a="http://schemas.openxmlformats.org/drawingml/2006/main">
               <a:ext uri="{FF2B5EF4-FFF2-40B4-BE49-F238E27FC236}">
-                <a16:creationId xmlns:a16="http://schemas.microsoft.com/office/drawing/2014/main" id="{38BEBF8C-7C99-4F5B-A403-14D5F616EFB0}"/>
+                <a16:creationId xmlns:a16="http://schemas.microsoft.com/office/drawing/2014/main" id="{FA912942-6E37-43D1-80C1-7472F05787CC}"/>
               </a:ext>
             </a:extLst>
           </p:cNvPr>
@@ -5434,7 +5434,7 @@
           <p:cNvPr id="17" name="">
             <a:extLst xmlns:a="http://schemas.openxmlformats.org/drawingml/2006/main">
               <a:ext uri="{FF2B5EF4-FFF2-40B4-BE49-F238E27FC236}">
-                <a16:creationId xmlns:a16="http://schemas.microsoft.com/office/drawing/2014/main" id="{560B219A-127D-479C-BB34-62A89E9A368D}"/>
+                <a16:creationId xmlns:a16="http://schemas.microsoft.com/office/drawing/2014/main" id="{00D30B87-FA00-46D5-B82A-ED7326E6B88F}"/>
               </a:ext>
             </a:extLst>
           </p:cNvPr>
@@ -5489,7 +5489,7 @@
           <p:cNvPr id="19" name="">
             <a:extLst xmlns:a="http://schemas.openxmlformats.org/drawingml/2006/main">
               <a:ext uri="{FF2B5EF4-FFF2-40B4-BE49-F238E27FC236}">
-                <a16:creationId xmlns:a16="http://schemas.microsoft.com/office/drawing/2014/main" id="{75B506EE-072A-4391-965B-19AE8DFF04AE}"/>
+                <a16:creationId xmlns:a16="http://schemas.microsoft.com/office/drawing/2014/main" id="{BD9F11B2-5D1C-489A-8EC0-102438AF003F}"/>
               </a:ext>
             </a:extLst>
           </p:cNvPr>
@@ -5546,7 +5546,7 @@
           <p:cNvPr id="20" name="">
             <a:extLst xmlns:a="http://schemas.openxmlformats.org/drawingml/2006/main">
               <a:ext uri="{FF2B5EF4-FFF2-40B4-BE49-F238E27FC236}">
-                <a16:creationId xmlns:a16="http://schemas.microsoft.com/office/drawing/2014/main" id="{6C9AA5ED-C89C-4781-8D79-E6E7E3771C90}"/>
+                <a16:creationId xmlns:a16="http://schemas.microsoft.com/office/drawing/2014/main" id="{48EDAE33-24B7-4501-A678-F784A32D7F10}"/>
               </a:ext>
             </a:extLst>
           </p:cNvPr>
@@ -5574,7 +5574,7 @@
           <p:cNvPr id="21" name="">
             <a:extLst xmlns:a="http://schemas.openxmlformats.org/drawingml/2006/main">
               <a:ext uri="{FF2B5EF4-FFF2-40B4-BE49-F238E27FC236}">
-                <a16:creationId xmlns:a16="http://schemas.microsoft.com/office/drawing/2014/main" id="{2735917E-8ECD-4662-8CE1-C79CE9EA5C23}"/>
+                <a16:creationId xmlns:a16="http://schemas.microsoft.com/office/drawing/2014/main" id="{716171CE-6885-4FD2-96B3-81249D61DB93}"/>
               </a:ext>
             </a:extLst>
           </p:cNvPr>
@@ -5629,7 +5629,7 @@
           <p:cNvPr id="23" name="">
             <a:extLst xmlns:a="http://schemas.openxmlformats.org/drawingml/2006/main">
               <a:ext uri="{FF2B5EF4-FFF2-40B4-BE49-F238E27FC236}">
-                <a16:creationId xmlns:a16="http://schemas.microsoft.com/office/drawing/2014/main" id="{897BEA85-C5E6-4059-B310-0D97B418EE7A}"/>
+                <a16:creationId xmlns:a16="http://schemas.microsoft.com/office/drawing/2014/main" id="{98A21676-EBC6-4EE7-9B89-0AEACA1FAEDD}"/>
               </a:ext>
             </a:extLst>
           </p:cNvPr>
@@ -5686,7 +5686,7 @@
           <p:cNvPr id="24" name="">
             <a:extLst xmlns:a="http://schemas.openxmlformats.org/drawingml/2006/main">
               <a:ext uri="{FF2B5EF4-FFF2-40B4-BE49-F238E27FC236}">
-                <a16:creationId xmlns:a16="http://schemas.microsoft.com/office/drawing/2014/main" id="{8CCF3824-1B6C-41BF-A9E4-82B45C7D9361}"/>
+                <a16:creationId xmlns:a16="http://schemas.microsoft.com/office/drawing/2014/main" id="{86E870B8-6401-498B-AAC4-4F4436517A04}"/>
               </a:ext>
             </a:extLst>
           </p:cNvPr>
@@ -5714,7 +5714,7 @@
           <p:cNvPr id="25" name="">
             <a:extLst xmlns:a="http://schemas.openxmlformats.org/drawingml/2006/main">
               <a:ext uri="{FF2B5EF4-FFF2-40B4-BE49-F238E27FC236}">
-                <a16:creationId xmlns:a16="http://schemas.microsoft.com/office/drawing/2014/main" id="{AE56F18D-0EC8-4444-9A12-DA064E1E8FE2}"/>
+                <a16:creationId xmlns:a16="http://schemas.microsoft.com/office/drawing/2014/main" id="{39E67AEA-1715-40F5-A03F-F4188F360246}"/>
               </a:ext>
             </a:extLst>
           </p:cNvPr>
@@ -5769,7 +5769,7 @@
           <p:cNvPr id="27" name="">
             <a:extLst xmlns:a="http://schemas.openxmlformats.org/drawingml/2006/main">
               <a:ext uri="{FF2B5EF4-FFF2-40B4-BE49-F238E27FC236}">
-                <a16:creationId xmlns:a16="http://schemas.microsoft.com/office/drawing/2014/main" id="{E24DDCA7-D390-42C7-B63B-9D4F6F29CDFB}"/>
+                <a16:creationId xmlns:a16="http://schemas.microsoft.com/office/drawing/2014/main" id="{F9194DF1-2B3A-457A-99C4-794B2B606FD3}"/>
               </a:ext>
             </a:extLst>
           </p:cNvPr>
@@ -5826,7 +5826,7 @@
           <p:cNvPr id="28" name="">
             <a:extLst xmlns:a="http://schemas.openxmlformats.org/drawingml/2006/main">
               <a:ext uri="{FF2B5EF4-FFF2-40B4-BE49-F238E27FC236}">
-                <a16:creationId xmlns:a16="http://schemas.microsoft.com/office/drawing/2014/main" id="{6DC71253-DA0A-4FFA-BABE-BDB81530379C}"/>
+                <a16:creationId xmlns:a16="http://schemas.microsoft.com/office/drawing/2014/main" id="{13C962E6-A769-4EED-8CF4-2B8F5172A4F1}"/>
               </a:ext>
             </a:extLst>
           </p:cNvPr>
@@ -5854,7 +5854,7 @@
           <p:cNvPr id="29" name="">
             <a:extLst xmlns:a="http://schemas.openxmlformats.org/drawingml/2006/main">
               <a:ext uri="{FF2B5EF4-FFF2-40B4-BE49-F238E27FC236}">
-                <a16:creationId xmlns:a16="http://schemas.microsoft.com/office/drawing/2014/main" id="{8E22C8AE-EEBC-4C43-A6EF-EB9AF624D3BF}"/>
+                <a16:creationId xmlns:a16="http://schemas.microsoft.com/office/drawing/2014/main" id="{FCBDD2EB-C7D1-426D-B38E-9CA92997DA9E}"/>
               </a:ext>
             </a:extLst>
           </p:cNvPr>
@@ -5909,7 +5909,7 @@
           <p:cNvPr id="31" name="">
             <a:extLst xmlns:a="http://schemas.openxmlformats.org/drawingml/2006/main">
               <a:ext uri="{FF2B5EF4-FFF2-40B4-BE49-F238E27FC236}">
-                <a16:creationId xmlns:a16="http://schemas.microsoft.com/office/drawing/2014/main" id="{1847955B-20AF-48E1-8886-BB4880BE33C7}"/>
+                <a16:creationId xmlns:a16="http://schemas.microsoft.com/office/drawing/2014/main" id="{5657F94A-F8A7-44C2-890A-DA47C7DF1DFF}"/>
               </a:ext>
             </a:extLst>
           </p:cNvPr>
@@ -5966,7 +5966,7 @@
           <p:cNvPr id="32" name="">
             <a:extLst xmlns:a="http://schemas.openxmlformats.org/drawingml/2006/main">
               <a:ext uri="{FF2B5EF4-FFF2-40B4-BE49-F238E27FC236}">
-                <a16:creationId xmlns:a16="http://schemas.microsoft.com/office/drawing/2014/main" id="{6A1BB398-1011-4F4C-BF9A-9FFC97A66D3F}"/>
+                <a16:creationId xmlns:a16="http://schemas.microsoft.com/office/drawing/2014/main" id="{9DBBB94F-4E48-4C23-B7B9-C9F68852DA5D}"/>
               </a:ext>
             </a:extLst>
           </p:cNvPr>
@@ -5994,7 +5994,7 @@
           <p:cNvPr id="33" name="">
             <a:extLst xmlns:a="http://schemas.openxmlformats.org/drawingml/2006/main">
               <a:ext uri="{FF2B5EF4-FFF2-40B4-BE49-F238E27FC236}">
-                <a16:creationId xmlns:a16="http://schemas.microsoft.com/office/drawing/2014/main" id="{5D4B98ED-2466-4E3B-8FE8-E0C9033BBD42}"/>
+                <a16:creationId xmlns:a16="http://schemas.microsoft.com/office/drawing/2014/main" id="{FFE7842A-7A40-4279-9CCC-18C00C3681F1}"/>
               </a:ext>
             </a:extLst>
           </p:cNvPr>
@@ -6049,7 +6049,7 @@
           <p:cNvPr id="35" name="">
             <a:extLst xmlns:a="http://schemas.openxmlformats.org/drawingml/2006/main">
               <a:ext uri="{FF2B5EF4-FFF2-40B4-BE49-F238E27FC236}">
-                <a16:creationId xmlns:a16="http://schemas.microsoft.com/office/drawing/2014/main" id="{080E8DB0-8CB0-43D0-A692-57DBF9CA237C}"/>
+                <a16:creationId xmlns:a16="http://schemas.microsoft.com/office/drawing/2014/main" id="{9DF66B36-119D-4530-B017-54E8DFC37FC9}"/>
               </a:ext>
             </a:extLst>
           </p:cNvPr>
@@ -6106,7 +6106,7 @@
           <p:cNvPr id="36" name="">
             <a:extLst xmlns:a="http://schemas.openxmlformats.org/drawingml/2006/main">
               <a:ext uri="{FF2B5EF4-FFF2-40B4-BE49-F238E27FC236}">
-                <a16:creationId xmlns:a16="http://schemas.microsoft.com/office/drawing/2014/main" id="{9B68E248-5194-4C49-BF13-55EDB174E560}"/>
+                <a16:creationId xmlns:a16="http://schemas.microsoft.com/office/drawing/2014/main" id="{65EF2FD1-FB8D-40FC-983E-7EC98E046C3A}"/>
               </a:ext>
             </a:extLst>
           </p:cNvPr>
@@ -6134,7 +6134,7 @@
           <p:cNvPr id="37" name="">
             <a:extLst xmlns:a="http://schemas.openxmlformats.org/drawingml/2006/main">
               <a:ext uri="{FF2B5EF4-FFF2-40B4-BE49-F238E27FC236}">
-                <a16:creationId xmlns:a16="http://schemas.microsoft.com/office/drawing/2014/main" id="{0AB10500-4984-42F4-8EE8-3AF4C7650F06}"/>
+                <a16:creationId xmlns:a16="http://schemas.microsoft.com/office/drawing/2014/main" id="{79720B0C-742D-45E0-A5AF-3129C6E76E0D}"/>
               </a:ext>
             </a:extLst>
           </p:cNvPr>
@@ -6189,7 +6189,7 @@
           <p:cNvPr id="39" name="">
             <a:extLst xmlns:a="http://schemas.openxmlformats.org/drawingml/2006/main">
               <a:ext uri="{FF2B5EF4-FFF2-40B4-BE49-F238E27FC236}">
-                <a16:creationId xmlns:a16="http://schemas.microsoft.com/office/drawing/2014/main" id="{E0C204F2-4B8B-4EF8-B688-70A001C646F5}"/>
+                <a16:creationId xmlns:a16="http://schemas.microsoft.com/office/drawing/2014/main" id="{A007A635-8F64-4ABD-A335-67874CF89D03}"/>
               </a:ext>
             </a:extLst>
           </p:cNvPr>
@@ -6246,7 +6246,7 @@
           <p:cNvPr id="40" name="">
             <a:extLst xmlns:a="http://schemas.openxmlformats.org/drawingml/2006/main">
               <a:ext uri="{FF2B5EF4-FFF2-40B4-BE49-F238E27FC236}">
-                <a16:creationId xmlns:a16="http://schemas.microsoft.com/office/drawing/2014/main" id="{DB91975E-192F-48E6-9A49-4DD3D1E55D9C}"/>
+                <a16:creationId xmlns:a16="http://schemas.microsoft.com/office/drawing/2014/main" id="{3BC55CFA-8239-465A-8513-A8569657BA3E}"/>
               </a:ext>
             </a:extLst>
           </p:cNvPr>
@@ -6274,7 +6274,7 @@
           <p:cNvPr id="41" name="">
             <a:extLst xmlns:a="http://schemas.openxmlformats.org/drawingml/2006/main">
               <a:ext uri="{FF2B5EF4-FFF2-40B4-BE49-F238E27FC236}">
-                <a16:creationId xmlns:a16="http://schemas.microsoft.com/office/drawing/2014/main" id="{725ECE17-2A83-4893-B7FE-F71DB3CD19DB}"/>
+                <a16:creationId xmlns:a16="http://schemas.microsoft.com/office/drawing/2014/main" id="{974E04EC-D54B-459C-8869-D2DE00236ECD}"/>
               </a:ext>
             </a:extLst>
           </p:cNvPr>
@@ -6329,7 +6329,7 @@
           <p:cNvPr id="43" name="">
             <a:extLst xmlns:a="http://schemas.openxmlformats.org/drawingml/2006/main">
               <a:ext uri="{FF2B5EF4-FFF2-40B4-BE49-F238E27FC236}">
-                <a16:creationId xmlns:a16="http://schemas.microsoft.com/office/drawing/2014/main" id="{02E3E93E-9317-45BC-9D9D-117EC12DA2BC}"/>
+                <a16:creationId xmlns:a16="http://schemas.microsoft.com/office/drawing/2014/main" id="{4F197424-9C16-46ED-A990-36055E7F005C}"/>
               </a:ext>
             </a:extLst>
           </p:cNvPr>
@@ -6386,7 +6386,7 @@
           <p:cNvPr id="44" name="">
             <a:extLst xmlns:a="http://schemas.openxmlformats.org/drawingml/2006/main">
               <a:ext uri="{FF2B5EF4-FFF2-40B4-BE49-F238E27FC236}">
-                <a16:creationId xmlns:a16="http://schemas.microsoft.com/office/drawing/2014/main" id="{EBAE1894-E417-4F27-81FA-CC10488B7798}"/>
+                <a16:creationId xmlns:a16="http://schemas.microsoft.com/office/drawing/2014/main" id="{D36731A4-6E57-4416-98B1-F8B262A1946C}"/>
               </a:ext>
             </a:extLst>
           </p:cNvPr>
@@ -6443,7 +6443,7 @@
           <p:cNvPr id="45" name="">
             <a:extLst xmlns:a="http://schemas.openxmlformats.org/drawingml/2006/main">
               <a:ext uri="{FF2B5EF4-FFF2-40B4-BE49-F238E27FC236}">
-                <a16:creationId xmlns:a16="http://schemas.microsoft.com/office/drawing/2014/main" id="{0C302ED7-9C42-440F-9576-A130A0A71C56}"/>
+                <a16:creationId xmlns:a16="http://schemas.microsoft.com/office/drawing/2014/main" id="{1BCEB6FA-0B30-49DE-888B-E7B234AF3103}"/>
               </a:ext>
             </a:extLst>
           </p:cNvPr>
@@ -6500,7 +6500,7 @@
                 <a:latin typeface="Hiragino Sans GB"/>
                 <a:ea typeface="Hiragino Sans GB"/>
                 <a:cs typeface="Hiragino Sans GB"/>
-                <a:hlinkClick xmlns:r="http://schemas.openxmlformats.org/officeDocument/2006/relationships" r:id="Rfacf48e7a01b4712"/>
+                <a:hlinkClick xmlns:r="http://schemas.openxmlformats.org/officeDocument/2006/relationships" r:id="R6511e0337ecd497a"/>
               </a:rPr>
               <a:t>MYA 实现与实测</a:t>
             </a:r>
@@ -6510,7 +6510,7 @@
     </p:spTree>
     <p:extLst>
       <p:ext uri="{BB962C8B-B14F-4D97-AF65-F5344CB8AC3E}">
-        <p14:creationId xmlns:p14="http://schemas.microsoft.com/office/powerpoint/2010/main" val="1440262480"/>
+        <p14:creationId xmlns:p14="http://schemas.microsoft.com/office/powerpoint/2010/main" val="454351823"/>
       </p:ext>
     </p:extLst>
   </p:cSld>
@@ -6541,7 +6541,7 @@
           <p:cNvPr id="11" name="">
             <a:extLst xmlns:a="http://schemas.openxmlformats.org/drawingml/2006/main">
               <a:ext uri="{FF2B5EF4-FFF2-40B4-BE49-F238E27FC236}">
-                <a16:creationId xmlns:a16="http://schemas.microsoft.com/office/drawing/2014/main" id="{385C8C08-660D-4567-A677-59A4BA62D7F1}"/>
+                <a16:creationId xmlns:a16="http://schemas.microsoft.com/office/drawing/2014/main" id="{0BDAED84-88E2-4618-BBBA-8F2ACDD6FE42}"/>
               </a:ext>
             </a:extLst>
           </p:cNvPr>
@@ -6598,7 +6598,7 @@
           <p:cNvPr id="2" name="">
             <a:extLst xmlns:a="http://schemas.openxmlformats.org/drawingml/2006/main">
               <a:ext uri="{FF2B5EF4-FFF2-40B4-BE49-F238E27FC236}">
-                <a16:creationId xmlns:a16="http://schemas.microsoft.com/office/drawing/2014/main" id="{C3614F9C-EF90-4427-AC77-F9CA8D150489}"/>
+                <a16:creationId xmlns:a16="http://schemas.microsoft.com/office/drawing/2014/main" id="{E361817E-F94A-4805-AD46-FD18331B3CF9}"/>
               </a:ext>
             </a:extLst>
           </p:cNvPr>
@@ -6655,7 +6655,7 @@
           <p:cNvPr id="3" name="">
             <a:extLst xmlns:a="http://schemas.openxmlformats.org/drawingml/2006/main">
               <a:ext uri="{FF2B5EF4-FFF2-40B4-BE49-F238E27FC236}">
-                <a16:creationId xmlns:a16="http://schemas.microsoft.com/office/drawing/2014/main" id="{63601AEF-E8D9-4388-A9D3-A042731307BE}"/>
+                <a16:creationId xmlns:a16="http://schemas.microsoft.com/office/drawing/2014/main" id="{DE1D26A4-356D-4EDE-B457-45D046733C56}"/>
               </a:ext>
             </a:extLst>
           </p:cNvPr>
@@ -6712,7 +6712,7 @@
           <p:cNvPr id="4" name="">
             <a:extLst xmlns:a="http://schemas.openxmlformats.org/drawingml/2006/main">
               <a:ext uri="{FF2B5EF4-FFF2-40B4-BE49-F238E27FC236}">
-                <a16:creationId xmlns:a16="http://schemas.microsoft.com/office/drawing/2014/main" id="{CC6B43A6-FB28-43B1-A7BA-A07AEB39DD6B}"/>
+                <a16:creationId xmlns:a16="http://schemas.microsoft.com/office/drawing/2014/main" id="{6976A029-5CB0-4A10-A5A2-324E8F62E9C3}"/>
               </a:ext>
             </a:extLst>
           </p:cNvPr>
@@ -6773,7 +6773,7 @@
           <p:nvPr/>
         </p:nvPicPr>
         <p:blipFill>
-          <a:blip xmlns:r="http://schemas.openxmlformats.org/officeDocument/2006/relationships" xmlns:a="http://schemas.openxmlformats.org/drawingml/2006/main" r:embed="R499c6e17d5e64203"/>
+          <a:blip xmlns:r="http://schemas.openxmlformats.org/officeDocument/2006/relationships" xmlns:a="http://schemas.openxmlformats.org/drawingml/2006/main" r:embed="Ra603df70cf6040d2"/>
           <a:stretch xmlns:a="http://schemas.openxmlformats.org/drawingml/2006/main"/>
         </p:blipFill>
         <p:spPr>
@@ -6791,7 +6791,7 @@
           <p:cNvPr id="6" name="">
             <a:extLst xmlns:a="http://schemas.openxmlformats.org/drawingml/2006/main">
               <a:ext uri="{FF2B5EF4-FFF2-40B4-BE49-F238E27FC236}">
-                <a16:creationId xmlns:a16="http://schemas.microsoft.com/office/drawing/2014/main" id="{20377D27-9504-4A7A-9505-B403C55E0B43}"/>
+                <a16:creationId xmlns:a16="http://schemas.microsoft.com/office/drawing/2014/main" id="{093E4CD7-E71F-4548-8180-52756A928445}"/>
               </a:ext>
             </a:extLst>
           </p:cNvPr>
@@ -6852,7 +6852,7 @@
           <p:nvPr/>
         </p:nvPicPr>
         <p:blipFill>
-          <a:blip xmlns:r="http://schemas.openxmlformats.org/officeDocument/2006/relationships" xmlns:a="http://schemas.openxmlformats.org/drawingml/2006/main" r:embed="Rc7afbbceb28e4d4e"/>
+          <a:blip xmlns:r="http://schemas.openxmlformats.org/officeDocument/2006/relationships" xmlns:a="http://schemas.openxmlformats.org/drawingml/2006/main" r:embed="R7d48fe3640bf4532"/>
           <a:stretch xmlns:a="http://schemas.openxmlformats.org/drawingml/2006/main"/>
         </p:blipFill>
         <p:spPr>
@@ -6870,7 +6870,7 @@
           <p:cNvPr id="8" name="">
             <a:extLst xmlns:a="http://schemas.openxmlformats.org/drawingml/2006/main">
               <a:ext uri="{FF2B5EF4-FFF2-40B4-BE49-F238E27FC236}">
-                <a16:creationId xmlns:a16="http://schemas.microsoft.com/office/drawing/2014/main" id="{20711741-D997-4DA1-A3C1-926A54252D0F}"/>
+                <a16:creationId xmlns:a16="http://schemas.microsoft.com/office/drawing/2014/main" id="{F0C4A7DC-83BE-46CD-898E-62E375F7F21F}"/>
               </a:ext>
             </a:extLst>
           </p:cNvPr>
@@ -6950,7 +6950,7 @@
           <p:cNvPr id="9" name="">
             <a:extLst xmlns:a="http://schemas.openxmlformats.org/drawingml/2006/main">
               <a:ext uri="{FF2B5EF4-FFF2-40B4-BE49-F238E27FC236}">
-                <a16:creationId xmlns:a16="http://schemas.microsoft.com/office/drawing/2014/main" id="{F3A2FF4F-5E8B-430E-8278-E9B17430AFC4}"/>
+                <a16:creationId xmlns:a16="http://schemas.microsoft.com/office/drawing/2014/main" id="{53A047A0-E7B2-4A49-96C6-E5850032826F}"/>
               </a:ext>
             </a:extLst>
           </p:cNvPr>
@@ -7007,7 +7007,7 @@
           <p:cNvPr id="10" name="">
             <a:extLst xmlns:a="http://schemas.openxmlformats.org/drawingml/2006/main">
               <a:ext uri="{FF2B5EF4-FFF2-40B4-BE49-F238E27FC236}">
-                <a16:creationId xmlns:a16="http://schemas.microsoft.com/office/drawing/2014/main" id="{C95C5AE3-20C2-40ED-BCA3-F04F7BBF2985}"/>
+                <a16:creationId xmlns:a16="http://schemas.microsoft.com/office/drawing/2014/main" id="{BE1C01BE-6D53-401F-B2D9-C9ECD13EF8ED}"/>
               </a:ext>
             </a:extLst>
           </p:cNvPr>
@@ -7064,7 +7064,7 @@
                 <a:latin typeface="Hiragino Sans GB"/>
                 <a:ea typeface="Hiragino Sans GB"/>
                 <a:cs typeface="Hiragino Sans GB"/>
-                <a:hlinkClick xmlns:r="http://schemas.openxmlformats.org/officeDocument/2006/relationships" r:id="R3ee40f2d4cd84a7e"/>
+                <a:hlinkClick xmlns:r="http://schemas.openxmlformats.org/officeDocument/2006/relationships" r:id="Raad30abd95644194"/>
               </a:rPr>
               <a:t>MYA 实现与实测</a:t>
             </a:r>
@@ -7074,7 +7074,7 @@
     </p:spTree>
     <p:extLst>
       <p:ext uri="{BB962C8B-B14F-4D97-AF65-F5344CB8AC3E}">
-        <p14:creationId xmlns:p14="http://schemas.microsoft.com/office/powerpoint/2010/main" val="1755329492"/>
+        <p14:creationId xmlns:p14="http://schemas.microsoft.com/office/powerpoint/2010/main" val="660661191"/>
       </p:ext>
     </p:extLst>
   </p:cSld>
@@ -7105,7 +7105,7 @@
           <p:cNvPr id="37" name="">
             <a:extLst xmlns:a="http://schemas.openxmlformats.org/drawingml/2006/main">
               <a:ext uri="{FF2B5EF4-FFF2-40B4-BE49-F238E27FC236}">
-                <a16:creationId xmlns:a16="http://schemas.microsoft.com/office/drawing/2014/main" id="{40F0B596-4CA0-450E-A8B8-58BB8FAD32AD}"/>
+                <a16:creationId xmlns:a16="http://schemas.microsoft.com/office/drawing/2014/main" id="{9A7CB4F2-DF19-4190-A261-37F351361E8D}"/>
               </a:ext>
             </a:extLst>
           </p:cNvPr>
@@ -7162,7 +7162,7 @@
           <p:cNvPr id="2" name="">
             <a:extLst xmlns:a="http://schemas.openxmlformats.org/drawingml/2006/main">
               <a:ext uri="{FF2B5EF4-FFF2-40B4-BE49-F238E27FC236}">
-                <a16:creationId xmlns:a16="http://schemas.microsoft.com/office/drawing/2014/main" id="{FB35DDFD-D8F8-49E8-B793-30E9A34DD6DF}"/>
+                <a16:creationId xmlns:a16="http://schemas.microsoft.com/office/drawing/2014/main" id="{61218552-DA18-46A0-81A9-B82AD918B7C1}"/>
               </a:ext>
             </a:extLst>
           </p:cNvPr>
@@ -7219,7 +7219,7 @@
           <p:cNvPr id="3" name="">
             <a:extLst xmlns:a="http://schemas.openxmlformats.org/drawingml/2006/main">
               <a:ext uri="{FF2B5EF4-FFF2-40B4-BE49-F238E27FC236}">
-                <a16:creationId xmlns:a16="http://schemas.microsoft.com/office/drawing/2014/main" id="{AF8BAFB8-8B1F-48B1-83FE-523D295ED017}"/>
+                <a16:creationId xmlns:a16="http://schemas.microsoft.com/office/drawing/2014/main" id="{C1906A21-518D-4F80-B155-2FCF8FE9D5C4}"/>
               </a:ext>
             </a:extLst>
           </p:cNvPr>
@@ -7276,7 +7276,7 @@
           <p:cNvPr id="4" name="">
             <a:extLst xmlns:a="http://schemas.openxmlformats.org/drawingml/2006/main">
               <a:ext uri="{FF2B5EF4-FFF2-40B4-BE49-F238E27FC236}">
-                <a16:creationId xmlns:a16="http://schemas.microsoft.com/office/drawing/2014/main" id="{F9E85246-9B8C-480E-B2FE-FC754B0A0187}"/>
+                <a16:creationId xmlns:a16="http://schemas.microsoft.com/office/drawing/2014/main" id="{91DDC321-BBEF-4133-AE90-34A6BC182100}"/>
               </a:ext>
             </a:extLst>
           </p:cNvPr>
@@ -7309,7 +7309,7 @@
           <p:cNvPr id="5" name="">
             <a:extLst xmlns:a="http://schemas.openxmlformats.org/drawingml/2006/main">
               <a:ext uri="{FF2B5EF4-FFF2-40B4-BE49-F238E27FC236}">
-                <a16:creationId xmlns:a16="http://schemas.microsoft.com/office/drawing/2014/main" id="{4014DAF3-E531-4180-AB75-D1A07F069E3E}"/>
+                <a16:creationId xmlns:a16="http://schemas.microsoft.com/office/drawing/2014/main" id="{DD4B593C-D252-497B-A10E-1215D980A63B}"/>
               </a:ext>
             </a:extLst>
           </p:cNvPr>
@@ -7366,7 +7366,7 @@
           <p:cNvPr id="6" name="">
             <a:extLst xmlns:a="http://schemas.openxmlformats.org/drawingml/2006/main">
               <a:ext uri="{FF2B5EF4-FFF2-40B4-BE49-F238E27FC236}">
-                <a16:creationId xmlns:a16="http://schemas.microsoft.com/office/drawing/2014/main" id="{A43884B5-A1C9-414A-A045-E12E54D7221B}"/>
+                <a16:creationId xmlns:a16="http://schemas.microsoft.com/office/drawing/2014/main" id="{2DB15118-909B-45BC-82F8-3BD575066DD6}"/>
               </a:ext>
             </a:extLst>
           </p:cNvPr>
@@ -7423,7 +7423,7 @@
           <p:cNvPr id="7" name="">
             <a:extLst xmlns:a="http://schemas.openxmlformats.org/drawingml/2006/main">
               <a:ext uri="{FF2B5EF4-FFF2-40B4-BE49-F238E27FC236}">
-                <a16:creationId xmlns:a16="http://schemas.microsoft.com/office/drawing/2014/main" id="{B3304ED6-21C2-4C7D-B64F-361E9FB2C94E}"/>
+                <a16:creationId xmlns:a16="http://schemas.microsoft.com/office/drawing/2014/main" id="{302F0564-5358-43A6-88DC-7BDFD594B9FC}"/>
               </a:ext>
             </a:extLst>
           </p:cNvPr>
@@ -7456,7 +7456,7 @@
           <p:cNvPr id="8" name="">
             <a:extLst xmlns:a="http://schemas.openxmlformats.org/drawingml/2006/main">
               <a:ext uri="{FF2B5EF4-FFF2-40B4-BE49-F238E27FC236}">
-                <a16:creationId xmlns:a16="http://schemas.microsoft.com/office/drawing/2014/main" id="{05634B4D-0C36-4206-8E5D-037141D0A8B0}"/>
+                <a16:creationId xmlns:a16="http://schemas.microsoft.com/office/drawing/2014/main" id="{D34285EF-E9C8-4289-9EB8-EB1C883D7CB9}"/>
               </a:ext>
             </a:extLst>
           </p:cNvPr>
@@ -7513,7 +7513,7 @@
           <p:cNvPr id="9" name="">
             <a:extLst xmlns:a="http://schemas.openxmlformats.org/drawingml/2006/main">
               <a:ext uri="{FF2B5EF4-FFF2-40B4-BE49-F238E27FC236}">
-                <a16:creationId xmlns:a16="http://schemas.microsoft.com/office/drawing/2014/main" id="{626AF918-5C65-4D97-8187-AC6DEBC45827}"/>
+                <a16:creationId xmlns:a16="http://schemas.microsoft.com/office/drawing/2014/main" id="{819B10CB-F8A7-445B-AF6F-33004D81F521}"/>
               </a:ext>
             </a:extLst>
           </p:cNvPr>
@@ -7570,7 +7570,7 @@
           <p:cNvPr id="10" name="">
             <a:extLst xmlns:a="http://schemas.openxmlformats.org/drawingml/2006/main">
               <a:ext uri="{FF2B5EF4-FFF2-40B4-BE49-F238E27FC236}">
-                <a16:creationId xmlns:a16="http://schemas.microsoft.com/office/drawing/2014/main" id="{2B5E8E8F-1A99-4A22-AEF5-62FB2121D409}"/>
+                <a16:creationId xmlns:a16="http://schemas.microsoft.com/office/drawing/2014/main" id="{A5734BB7-E5D6-4007-9131-B9199863EFD7}"/>
               </a:ext>
             </a:extLst>
           </p:cNvPr>
@@ -7603,7 +7603,7 @@
           <p:cNvPr id="11" name="">
             <a:extLst xmlns:a="http://schemas.openxmlformats.org/drawingml/2006/main">
               <a:ext uri="{FF2B5EF4-FFF2-40B4-BE49-F238E27FC236}">
-                <a16:creationId xmlns:a16="http://schemas.microsoft.com/office/drawing/2014/main" id="{A5346A67-1972-49D6-AAC3-8C937B6EC4ED}"/>
+                <a16:creationId xmlns:a16="http://schemas.microsoft.com/office/drawing/2014/main" id="{665E22DB-C8E7-4B8E-BF88-FEB434393A77}"/>
               </a:ext>
             </a:extLst>
           </p:cNvPr>
@@ -7660,7 +7660,7 @@
           <p:cNvPr id="12" name="">
             <a:extLst xmlns:a="http://schemas.openxmlformats.org/drawingml/2006/main">
               <a:ext uri="{FF2B5EF4-FFF2-40B4-BE49-F238E27FC236}">
-                <a16:creationId xmlns:a16="http://schemas.microsoft.com/office/drawing/2014/main" id="{67388033-B727-4D17-81FC-ABAB5107AE9A}"/>
+                <a16:creationId xmlns:a16="http://schemas.microsoft.com/office/drawing/2014/main" id="{0D0F3033-6529-4AA9-8A2E-3950C5E4E054}"/>
               </a:ext>
             </a:extLst>
           </p:cNvPr>
@@ -7771,7 +7771,7 @@
           <p:cNvPr id="15" name="">
             <a:extLst xmlns:a="http://schemas.openxmlformats.org/drawingml/2006/main">
               <a:ext uri="{FF2B5EF4-FFF2-40B4-BE49-F238E27FC236}">
-                <a16:creationId xmlns:a16="http://schemas.microsoft.com/office/drawing/2014/main" id="{7D5C5333-D2D3-4BB6-AC54-4EFC8BC9B128}"/>
+                <a16:creationId xmlns:a16="http://schemas.microsoft.com/office/drawing/2014/main" id="{0454DD73-E492-45FC-A50C-86D2FED7D3E8}"/>
               </a:ext>
             </a:extLst>
           </p:cNvPr>
@@ -7828,7 +7828,7 @@
           <p:cNvPr id="16" name="">
             <a:extLst xmlns:a="http://schemas.openxmlformats.org/drawingml/2006/main">
               <a:ext uri="{FF2B5EF4-FFF2-40B4-BE49-F238E27FC236}">
-                <a16:creationId xmlns:a16="http://schemas.microsoft.com/office/drawing/2014/main" id="{99AF6478-0AE0-4923-A93F-FD5FC84FD16F}"/>
+                <a16:creationId xmlns:a16="http://schemas.microsoft.com/office/drawing/2014/main" id="{5C4B1F6B-34FA-4B78-8286-BD51494D811E}"/>
               </a:ext>
             </a:extLst>
           </p:cNvPr>
@@ -7861,7 +7861,7 @@
           <p:cNvPr id="17" name="">
             <a:extLst xmlns:a="http://schemas.openxmlformats.org/drawingml/2006/main">
               <a:ext uri="{FF2B5EF4-FFF2-40B4-BE49-F238E27FC236}">
-                <a16:creationId xmlns:a16="http://schemas.microsoft.com/office/drawing/2014/main" id="{F30529DF-4974-4085-8CA4-B3C8EEA0E752}"/>
+                <a16:creationId xmlns:a16="http://schemas.microsoft.com/office/drawing/2014/main" id="{B1662DBF-55E5-4229-9C56-177C50BCB787}"/>
               </a:ext>
             </a:extLst>
           </p:cNvPr>
@@ -7918,7 +7918,7 @@
           <p:cNvPr id="18" name="">
             <a:extLst xmlns:a="http://schemas.openxmlformats.org/drawingml/2006/main">
               <a:ext uri="{FF2B5EF4-FFF2-40B4-BE49-F238E27FC236}">
-                <a16:creationId xmlns:a16="http://schemas.microsoft.com/office/drawing/2014/main" id="{697D988D-11C6-46E4-AFE2-3E26B29BC656}"/>
+                <a16:creationId xmlns:a16="http://schemas.microsoft.com/office/drawing/2014/main" id="{84CF0B3F-643E-4880-85E5-F8DF74443597}"/>
               </a:ext>
             </a:extLst>
           </p:cNvPr>
@@ -7975,7 +7975,7 @@
           <p:cNvPr id="19" name="">
             <a:extLst xmlns:a="http://schemas.openxmlformats.org/drawingml/2006/main">
               <a:ext uri="{FF2B5EF4-FFF2-40B4-BE49-F238E27FC236}">
-                <a16:creationId xmlns:a16="http://schemas.microsoft.com/office/drawing/2014/main" id="{FDDE07CF-F8FB-4C1E-A046-EA3C845953AD}"/>
+                <a16:creationId xmlns:a16="http://schemas.microsoft.com/office/drawing/2014/main" id="{65E88E78-1D8F-4C63-81DA-B6FA99C83403}"/>
               </a:ext>
             </a:extLst>
           </p:cNvPr>
@@ -8008,7 +8008,7 @@
           <p:cNvPr id="20" name="">
             <a:extLst xmlns:a="http://schemas.openxmlformats.org/drawingml/2006/main">
               <a:ext uri="{FF2B5EF4-FFF2-40B4-BE49-F238E27FC236}">
-                <a16:creationId xmlns:a16="http://schemas.microsoft.com/office/drawing/2014/main" id="{37AFA04D-1F4A-40F3-ACBD-74D8B3656711}"/>
+                <a16:creationId xmlns:a16="http://schemas.microsoft.com/office/drawing/2014/main" id="{40D3EE9F-64D1-477A-9636-9437570F9FC3}"/>
               </a:ext>
             </a:extLst>
           </p:cNvPr>
@@ -8065,7 +8065,7 @@
           <p:cNvPr id="21" name="">
             <a:extLst xmlns:a="http://schemas.openxmlformats.org/drawingml/2006/main">
               <a:ext uri="{FF2B5EF4-FFF2-40B4-BE49-F238E27FC236}">
-                <a16:creationId xmlns:a16="http://schemas.microsoft.com/office/drawing/2014/main" id="{8C4032C6-2F6B-4E86-9FB4-6284D144D616}"/>
+                <a16:creationId xmlns:a16="http://schemas.microsoft.com/office/drawing/2014/main" id="{B53A91D7-3B21-402E-A38B-E24FC616EB51}"/>
               </a:ext>
             </a:extLst>
           </p:cNvPr>
@@ -8176,7 +8176,7 @@
           <p:cNvPr id="24" name="">
             <a:extLst xmlns:a="http://schemas.openxmlformats.org/drawingml/2006/main">
               <a:ext uri="{FF2B5EF4-FFF2-40B4-BE49-F238E27FC236}">
-                <a16:creationId xmlns:a16="http://schemas.microsoft.com/office/drawing/2014/main" id="{9D956752-A27C-41AA-9C50-53C0CFFC566E}"/>
+                <a16:creationId xmlns:a16="http://schemas.microsoft.com/office/drawing/2014/main" id="{C94BBC52-B137-49F2-860A-A09982925C0B}"/>
               </a:ext>
             </a:extLst>
           </p:cNvPr>
@@ -8204,7 +8204,7 @@
           <p:cNvPr id="25" name="">
             <a:extLst xmlns:a="http://schemas.openxmlformats.org/drawingml/2006/main">
               <a:ext uri="{FF2B5EF4-FFF2-40B4-BE49-F238E27FC236}">
-                <a16:creationId xmlns:a16="http://schemas.microsoft.com/office/drawing/2014/main" id="{814F28D8-6135-4AEF-A84F-22DFD8B75D11}"/>
+                <a16:creationId xmlns:a16="http://schemas.microsoft.com/office/drawing/2014/main" id="{D827F19B-A372-406C-84A2-285B418F65E2}"/>
               </a:ext>
             </a:extLst>
           </p:cNvPr>
@@ -8259,7 +8259,7 @@
           <p:cNvPr id="27" name="">
             <a:extLst xmlns:a="http://schemas.openxmlformats.org/drawingml/2006/main">
               <a:ext uri="{FF2B5EF4-FFF2-40B4-BE49-F238E27FC236}">
-                <a16:creationId xmlns:a16="http://schemas.microsoft.com/office/drawing/2014/main" id="{06B86178-318C-49AF-8600-9AD6E361E9DB}"/>
+                <a16:creationId xmlns:a16="http://schemas.microsoft.com/office/drawing/2014/main" id="{E0D3A626-B887-4C41-8A2D-43C4C8FF3566}"/>
               </a:ext>
             </a:extLst>
           </p:cNvPr>
@@ -8287,7 +8287,7 @@
           <p:cNvPr id="28" name="">
             <a:extLst xmlns:a="http://schemas.openxmlformats.org/drawingml/2006/main">
               <a:ext uri="{FF2B5EF4-FFF2-40B4-BE49-F238E27FC236}">
-                <a16:creationId xmlns:a16="http://schemas.microsoft.com/office/drawing/2014/main" id="{0AB93AD0-5FC8-4D04-879F-14EF49E44FFD}"/>
+                <a16:creationId xmlns:a16="http://schemas.microsoft.com/office/drawing/2014/main" id="{455E4616-E679-4CF1-A569-2C4AE25486DB}"/>
               </a:ext>
             </a:extLst>
           </p:cNvPr>
@@ -8342,7 +8342,7 @@
           <p:cNvPr id="30" name="">
             <a:extLst xmlns:a="http://schemas.openxmlformats.org/drawingml/2006/main">
               <a:ext uri="{FF2B5EF4-FFF2-40B4-BE49-F238E27FC236}">
-                <a16:creationId xmlns:a16="http://schemas.microsoft.com/office/drawing/2014/main" id="{794D9D3C-2ECE-493D-A5F5-18D3F1CE6BAE}"/>
+                <a16:creationId xmlns:a16="http://schemas.microsoft.com/office/drawing/2014/main" id="{5AC3CEFD-9EA5-45FA-BAA1-1A3F70251E22}"/>
               </a:ext>
             </a:extLst>
           </p:cNvPr>
@@ -8370,7 +8370,7 @@
           <p:cNvPr id="31" name="">
             <a:extLst xmlns:a="http://schemas.openxmlformats.org/drawingml/2006/main">
               <a:ext uri="{FF2B5EF4-FFF2-40B4-BE49-F238E27FC236}">
-                <a16:creationId xmlns:a16="http://schemas.microsoft.com/office/drawing/2014/main" id="{C241CFA7-67DD-4882-859F-2A60B0B14BF3}"/>
+                <a16:creationId xmlns:a16="http://schemas.microsoft.com/office/drawing/2014/main" id="{56B1504B-5D1D-427A-96CF-43FD5A9EC316}"/>
               </a:ext>
             </a:extLst>
           </p:cNvPr>
@@ -8425,7 +8425,7 @@
           <p:cNvPr id="33" name="">
             <a:extLst xmlns:a="http://schemas.openxmlformats.org/drawingml/2006/main">
               <a:ext uri="{FF2B5EF4-FFF2-40B4-BE49-F238E27FC236}">
-                <a16:creationId xmlns:a16="http://schemas.microsoft.com/office/drawing/2014/main" id="{469AFE33-0849-4931-93B0-299E2AD08339}"/>
+                <a16:creationId xmlns:a16="http://schemas.microsoft.com/office/drawing/2014/main" id="{C292E7B4-88BC-4BD5-ACC7-19A312A6DD72}"/>
               </a:ext>
             </a:extLst>
           </p:cNvPr>
@@ -8482,7 +8482,7 @@
           <p:cNvPr id="34" name="">
             <a:extLst xmlns:a="http://schemas.openxmlformats.org/drawingml/2006/main">
               <a:ext uri="{FF2B5EF4-FFF2-40B4-BE49-F238E27FC236}">
-                <a16:creationId xmlns:a16="http://schemas.microsoft.com/office/drawing/2014/main" id="{309E455A-815A-47F1-B755-23FC0F7D02B0}"/>
+                <a16:creationId xmlns:a16="http://schemas.microsoft.com/office/drawing/2014/main" id="{71477166-5F53-4C1E-9E0E-02B554E0EF29}"/>
               </a:ext>
             </a:extLst>
           </p:cNvPr>
@@ -8562,7 +8562,7 @@
           <p:cNvPr id="35" name="">
             <a:extLst xmlns:a="http://schemas.openxmlformats.org/drawingml/2006/main">
               <a:ext uri="{FF2B5EF4-FFF2-40B4-BE49-F238E27FC236}">
-                <a16:creationId xmlns:a16="http://schemas.microsoft.com/office/drawing/2014/main" id="{B2808328-6048-4B88-B4DF-F56596C824C9}"/>
+                <a16:creationId xmlns:a16="http://schemas.microsoft.com/office/drawing/2014/main" id="{E97B9CE3-EBC9-4679-8257-05C24ED97C09}"/>
               </a:ext>
             </a:extLst>
           </p:cNvPr>
@@ -8619,7 +8619,7 @@
           <p:cNvPr id="36" name="">
             <a:extLst xmlns:a="http://schemas.openxmlformats.org/drawingml/2006/main">
               <a:ext uri="{FF2B5EF4-FFF2-40B4-BE49-F238E27FC236}">
-                <a16:creationId xmlns:a16="http://schemas.microsoft.com/office/drawing/2014/main" id="{35DC93F9-75A1-41B3-9450-226E676206B7}"/>
+                <a16:creationId xmlns:a16="http://schemas.microsoft.com/office/drawing/2014/main" id="{DF41BFE4-F99D-4E99-A61B-3F644EFEACF9}"/>
               </a:ext>
             </a:extLst>
           </p:cNvPr>
@@ -8676,7 +8676,7 @@
                 <a:latin typeface="Hiragino Sans GB"/>
                 <a:ea typeface="Hiragino Sans GB"/>
                 <a:cs typeface="Hiragino Sans GB"/>
-                <a:hlinkClick xmlns:r="http://schemas.openxmlformats.org/officeDocument/2006/relationships" r:id="Rb646dcdaa1b24982"/>
+                <a:hlinkClick xmlns:r="http://schemas.openxmlformats.org/officeDocument/2006/relationships" r:id="R186ff80aa7d24466"/>
               </a:rPr>
               <a:t>MYA 实现与实测</a:t>
             </a:r>
@@ -8686,7 +8686,7 @@
     </p:spTree>
     <p:extLst>
       <p:ext uri="{BB962C8B-B14F-4D97-AF65-F5344CB8AC3E}">
-        <p14:creationId xmlns:p14="http://schemas.microsoft.com/office/powerpoint/2010/main" val="830667289"/>
+        <p14:creationId xmlns:p14="http://schemas.microsoft.com/office/powerpoint/2010/main" val="1677194942"/>
       </p:ext>
     </p:extLst>
   </p:cSld>
@@ -8717,7 +8717,7 @@
           <p:cNvPr id="42" name="">
             <a:extLst xmlns:a="http://schemas.openxmlformats.org/drawingml/2006/main">
               <a:ext uri="{FF2B5EF4-FFF2-40B4-BE49-F238E27FC236}">
-                <a16:creationId xmlns:a16="http://schemas.microsoft.com/office/drawing/2014/main" id="{8A3451FF-348A-4D06-95A9-AB3CC0ABE685}"/>
+                <a16:creationId xmlns:a16="http://schemas.microsoft.com/office/drawing/2014/main" id="{56D9C3F3-2436-4E82-BA04-B6A77A16C974}"/>
               </a:ext>
             </a:extLst>
           </p:cNvPr>
@@ -8774,7 +8774,7 @@
           <p:cNvPr id="2" name="">
             <a:extLst xmlns:a="http://schemas.openxmlformats.org/drawingml/2006/main">
               <a:ext uri="{FF2B5EF4-FFF2-40B4-BE49-F238E27FC236}">
-                <a16:creationId xmlns:a16="http://schemas.microsoft.com/office/drawing/2014/main" id="{34D27818-6F09-49EC-BE59-F06EE2E14180}"/>
+                <a16:creationId xmlns:a16="http://schemas.microsoft.com/office/drawing/2014/main" id="{A05BFAA0-E210-4A8D-968B-0E708A27D4FB}"/>
               </a:ext>
             </a:extLst>
           </p:cNvPr>
@@ -8831,7 +8831,7 @@
           <p:cNvPr id="3" name="">
             <a:extLst xmlns:a="http://schemas.openxmlformats.org/drawingml/2006/main">
               <a:ext uri="{FF2B5EF4-FFF2-40B4-BE49-F238E27FC236}">
-                <a16:creationId xmlns:a16="http://schemas.microsoft.com/office/drawing/2014/main" id="{5E378A6B-246B-4E2F-A8F2-5649B2B745B8}"/>
+                <a16:creationId xmlns:a16="http://schemas.microsoft.com/office/drawing/2014/main" id="{C7543F5B-89D3-4E40-BEB7-41BDAB3252FF}"/>
               </a:ext>
             </a:extLst>
           </p:cNvPr>
@@ -8888,7 +8888,7 @@
           <p:cNvPr id="4" name="">
             <a:extLst xmlns:a="http://schemas.openxmlformats.org/drawingml/2006/main">
               <a:ext uri="{FF2B5EF4-FFF2-40B4-BE49-F238E27FC236}">
-                <a16:creationId xmlns:a16="http://schemas.microsoft.com/office/drawing/2014/main" id="{5BA59F8F-581D-4BAD-BCCF-998FA9A06E05}"/>
+                <a16:creationId xmlns:a16="http://schemas.microsoft.com/office/drawing/2014/main" id="{3F5D0FC0-59F7-44BE-BF83-3B50E1ABE199}"/>
               </a:ext>
             </a:extLst>
           </p:cNvPr>
@@ -8945,7 +8945,7 @@
           <p:cNvPr id="5" name="">
             <a:extLst xmlns:a="http://schemas.openxmlformats.org/drawingml/2006/main">
               <a:ext uri="{FF2B5EF4-FFF2-40B4-BE49-F238E27FC236}">
-                <a16:creationId xmlns:a16="http://schemas.microsoft.com/office/drawing/2014/main" id="{F3268172-CB61-4C7D-872E-633DFCDD21EE}"/>
+                <a16:creationId xmlns:a16="http://schemas.microsoft.com/office/drawing/2014/main" id="{F934D019-F194-4C3B-9B81-DBF448A9FF7D}"/>
               </a:ext>
             </a:extLst>
           </p:cNvPr>
@@ -8973,7 +8973,7 @@
           <p:cNvPr id="6" name="">
             <a:extLst xmlns:a="http://schemas.openxmlformats.org/drawingml/2006/main">
               <a:ext uri="{FF2B5EF4-FFF2-40B4-BE49-F238E27FC236}">
-                <a16:creationId xmlns:a16="http://schemas.microsoft.com/office/drawing/2014/main" id="{5E2982BD-1A16-45FB-BFC8-C63F4FEAB460}"/>
+                <a16:creationId xmlns:a16="http://schemas.microsoft.com/office/drawing/2014/main" id="{662D50EE-C69D-4009-9F4B-47A6391AC22F}"/>
               </a:ext>
             </a:extLst>
           </p:cNvPr>
@@ -9028,7 +9028,7 @@
           <p:cNvPr id="8" name="">
             <a:extLst xmlns:a="http://schemas.openxmlformats.org/drawingml/2006/main">
               <a:ext uri="{FF2B5EF4-FFF2-40B4-BE49-F238E27FC236}">
-                <a16:creationId xmlns:a16="http://schemas.microsoft.com/office/drawing/2014/main" id="{E1A00DF2-9860-4D61-AEE7-15507D500249}"/>
+                <a16:creationId xmlns:a16="http://schemas.microsoft.com/office/drawing/2014/main" id="{D3142AD9-11C3-4C26-A076-3C9AE118920B}"/>
               </a:ext>
             </a:extLst>
           </p:cNvPr>
@@ -9085,7 +9085,7 @@
           <p:cNvPr id="9" name="">
             <a:extLst xmlns:a="http://schemas.openxmlformats.org/drawingml/2006/main">
               <a:ext uri="{FF2B5EF4-FFF2-40B4-BE49-F238E27FC236}">
-                <a16:creationId xmlns:a16="http://schemas.microsoft.com/office/drawing/2014/main" id="{935C88F1-7470-4D46-9BCB-C5F7439581EB}"/>
+                <a16:creationId xmlns:a16="http://schemas.microsoft.com/office/drawing/2014/main" id="{4794FCA3-6289-46A2-ABB0-FB0BD4E022B3}"/>
               </a:ext>
             </a:extLst>
           </p:cNvPr>
@@ -9113,7 +9113,7 @@
           <p:cNvPr id="10" name="">
             <a:extLst xmlns:a="http://schemas.openxmlformats.org/drawingml/2006/main">
               <a:ext uri="{FF2B5EF4-FFF2-40B4-BE49-F238E27FC236}">
-                <a16:creationId xmlns:a16="http://schemas.microsoft.com/office/drawing/2014/main" id="{2010D38F-AFB6-4109-8739-0003BC975110}"/>
+                <a16:creationId xmlns:a16="http://schemas.microsoft.com/office/drawing/2014/main" id="{56A860E0-DF94-4485-94CD-73E933E39AC7}"/>
               </a:ext>
             </a:extLst>
           </p:cNvPr>
@@ -9168,7 +9168,7 @@
           <p:cNvPr id="12" name="">
             <a:extLst xmlns:a="http://schemas.openxmlformats.org/drawingml/2006/main">
               <a:ext uri="{FF2B5EF4-FFF2-40B4-BE49-F238E27FC236}">
-                <a16:creationId xmlns:a16="http://schemas.microsoft.com/office/drawing/2014/main" id="{3F705AD8-D3FC-4BF1-ADDA-CF2D4F7A4B2D}"/>
+                <a16:creationId xmlns:a16="http://schemas.microsoft.com/office/drawing/2014/main" id="{13B7F494-8246-46ED-B16A-A2257EE713BD}"/>
               </a:ext>
             </a:extLst>
           </p:cNvPr>
@@ -9225,7 +9225,7 @@
           <p:cNvPr id="13" name="">
             <a:extLst xmlns:a="http://schemas.openxmlformats.org/drawingml/2006/main">
               <a:ext uri="{FF2B5EF4-FFF2-40B4-BE49-F238E27FC236}">
-                <a16:creationId xmlns:a16="http://schemas.microsoft.com/office/drawing/2014/main" id="{1AFA8EAA-040D-41FC-99AA-E786FFB9BD37}"/>
+                <a16:creationId xmlns:a16="http://schemas.microsoft.com/office/drawing/2014/main" id="{D8E974C2-770D-4913-AE1C-1B4BFBF60614}"/>
               </a:ext>
             </a:extLst>
           </p:cNvPr>
@@ -9253,7 +9253,7 @@
           <p:cNvPr id="14" name="">
             <a:extLst xmlns:a="http://schemas.openxmlformats.org/drawingml/2006/main">
               <a:ext uri="{FF2B5EF4-FFF2-40B4-BE49-F238E27FC236}">
-                <a16:creationId xmlns:a16="http://schemas.microsoft.com/office/drawing/2014/main" id="{1991CBEC-F598-4A8B-A6CC-C88E45467360}"/>
+                <a16:creationId xmlns:a16="http://schemas.microsoft.com/office/drawing/2014/main" id="{E58794CA-A9CA-47D2-80C7-72835295352F}"/>
               </a:ext>
             </a:extLst>
           </p:cNvPr>
@@ -9308,7 +9308,7 @@
           <p:cNvPr id="16" name="">
             <a:extLst xmlns:a="http://schemas.openxmlformats.org/drawingml/2006/main">
               <a:ext uri="{FF2B5EF4-FFF2-40B4-BE49-F238E27FC236}">
-                <a16:creationId xmlns:a16="http://schemas.microsoft.com/office/drawing/2014/main" id="{CC940049-3C94-4361-A13F-8ECC6841FC74}"/>
+                <a16:creationId xmlns:a16="http://schemas.microsoft.com/office/drawing/2014/main" id="{79FB9382-53D5-4934-85F2-9B23C9218520}"/>
               </a:ext>
             </a:extLst>
           </p:cNvPr>
@@ -9336,7 +9336,7 @@
           <p:cNvPr id="17" name="">
             <a:extLst xmlns:a="http://schemas.openxmlformats.org/drawingml/2006/main">
               <a:ext uri="{FF2B5EF4-FFF2-40B4-BE49-F238E27FC236}">
-                <a16:creationId xmlns:a16="http://schemas.microsoft.com/office/drawing/2014/main" id="{64E2820A-AE27-4DA9-A9B7-2C8EBD864AD1}"/>
+                <a16:creationId xmlns:a16="http://schemas.microsoft.com/office/drawing/2014/main" id="{87FB04DF-65BF-4EC8-819E-86878384FCBF}"/>
               </a:ext>
             </a:extLst>
           </p:cNvPr>
@@ -9391,7 +9391,7 @@
           <p:cNvPr id="19" name="">
             <a:extLst xmlns:a="http://schemas.openxmlformats.org/drawingml/2006/main">
               <a:ext uri="{FF2B5EF4-FFF2-40B4-BE49-F238E27FC236}">
-                <a16:creationId xmlns:a16="http://schemas.microsoft.com/office/drawing/2014/main" id="{660D1239-DC85-4B87-B5AE-5D51D8056E8E}"/>
+                <a16:creationId xmlns:a16="http://schemas.microsoft.com/office/drawing/2014/main" id="{BD189D2F-3CE1-4689-A020-E69706E5FADF}"/>
               </a:ext>
             </a:extLst>
           </p:cNvPr>
@@ -9448,7 +9448,7 @@
           <p:cNvPr id="20" name="">
             <a:extLst xmlns:a="http://schemas.openxmlformats.org/drawingml/2006/main">
               <a:ext uri="{FF2B5EF4-FFF2-40B4-BE49-F238E27FC236}">
-                <a16:creationId xmlns:a16="http://schemas.microsoft.com/office/drawing/2014/main" id="{1FEA4C4D-F0BD-4A4A-9FD5-59E3E5B80E51}"/>
+                <a16:creationId xmlns:a16="http://schemas.microsoft.com/office/drawing/2014/main" id="{61477CFE-E842-4BBC-B9DF-0795AA2B94E4}"/>
               </a:ext>
             </a:extLst>
           </p:cNvPr>
@@ -9476,7 +9476,7 @@
           <p:cNvPr id="21" name="">
             <a:extLst xmlns:a="http://schemas.openxmlformats.org/drawingml/2006/main">
               <a:ext uri="{FF2B5EF4-FFF2-40B4-BE49-F238E27FC236}">
-                <a16:creationId xmlns:a16="http://schemas.microsoft.com/office/drawing/2014/main" id="{344BACB0-6E81-426B-8AD1-0F09672F135F}"/>
+                <a16:creationId xmlns:a16="http://schemas.microsoft.com/office/drawing/2014/main" id="{1622967E-6D91-41C4-8390-DF2CD3EDCFF0}"/>
               </a:ext>
             </a:extLst>
           </p:cNvPr>
@@ -9531,7 +9531,7 @@
           <p:cNvPr id="23" name="">
             <a:extLst xmlns:a="http://schemas.openxmlformats.org/drawingml/2006/main">
               <a:ext uri="{FF2B5EF4-FFF2-40B4-BE49-F238E27FC236}">
-                <a16:creationId xmlns:a16="http://schemas.microsoft.com/office/drawing/2014/main" id="{398B961A-ABB8-48E5-BE12-04D36597FDF3}"/>
+                <a16:creationId xmlns:a16="http://schemas.microsoft.com/office/drawing/2014/main" id="{A4C0E53B-DB7E-4BE4-8B72-E5E0F79B3E65}"/>
               </a:ext>
             </a:extLst>
           </p:cNvPr>
@@ -9588,7 +9588,7 @@
           <p:cNvPr id="24" name="">
             <a:extLst xmlns:a="http://schemas.openxmlformats.org/drawingml/2006/main">
               <a:ext uri="{FF2B5EF4-FFF2-40B4-BE49-F238E27FC236}">
-                <a16:creationId xmlns:a16="http://schemas.microsoft.com/office/drawing/2014/main" id="{94FCA08B-8830-4EAA-9F6A-8BA687515D61}"/>
+                <a16:creationId xmlns:a16="http://schemas.microsoft.com/office/drawing/2014/main" id="{D54CFA3E-C88B-4AF6-8F98-EF69F7298A19}"/>
               </a:ext>
             </a:extLst>
           </p:cNvPr>
@@ -9616,7 +9616,7 @@
           <p:cNvPr id="25" name="">
             <a:extLst xmlns:a="http://schemas.openxmlformats.org/drawingml/2006/main">
               <a:ext uri="{FF2B5EF4-FFF2-40B4-BE49-F238E27FC236}">
-                <a16:creationId xmlns:a16="http://schemas.microsoft.com/office/drawing/2014/main" id="{6F32D4F4-E3C4-4A75-A6A2-AC77F3F7CCBF}"/>
+                <a16:creationId xmlns:a16="http://schemas.microsoft.com/office/drawing/2014/main" id="{1068F1CA-ECEC-412E-BA23-5F11B5CD22D8}"/>
               </a:ext>
             </a:extLst>
           </p:cNvPr>
@@ -9671,7 +9671,7 @@
           <p:cNvPr id="27" name="">
             <a:extLst xmlns:a="http://schemas.openxmlformats.org/drawingml/2006/main">
               <a:ext uri="{FF2B5EF4-FFF2-40B4-BE49-F238E27FC236}">
-                <a16:creationId xmlns:a16="http://schemas.microsoft.com/office/drawing/2014/main" id="{2DD247D0-EB52-4E15-96B0-5D1F733AE17E}"/>
+                <a16:creationId xmlns:a16="http://schemas.microsoft.com/office/drawing/2014/main" id="{5F1C13BC-BD2A-4F84-9B4E-28F9291B4CBC}"/>
               </a:ext>
             </a:extLst>
           </p:cNvPr>
@@ -9728,7 +9728,7 @@
           <p:cNvPr id="28" name="">
             <a:extLst xmlns:a="http://schemas.openxmlformats.org/drawingml/2006/main">
               <a:ext uri="{FF2B5EF4-FFF2-40B4-BE49-F238E27FC236}">
-                <a16:creationId xmlns:a16="http://schemas.microsoft.com/office/drawing/2014/main" id="{4FF49B35-6645-4A7C-8789-6249C71ED1EA}"/>
+                <a16:creationId xmlns:a16="http://schemas.microsoft.com/office/drawing/2014/main" id="{A27CB9ED-9745-45BE-8E4F-1A52E1F58820}"/>
               </a:ext>
             </a:extLst>
           </p:cNvPr>
@@ -9756,7 +9756,7 @@
           <p:cNvPr id="29" name="">
             <a:extLst xmlns:a="http://schemas.openxmlformats.org/drawingml/2006/main">
               <a:ext uri="{FF2B5EF4-FFF2-40B4-BE49-F238E27FC236}">
-                <a16:creationId xmlns:a16="http://schemas.microsoft.com/office/drawing/2014/main" id="{3C48767B-360C-43A4-B21D-AF9A211629FB}"/>
+                <a16:creationId xmlns:a16="http://schemas.microsoft.com/office/drawing/2014/main" id="{A793C966-8845-4A54-95AD-43D486387B04}"/>
               </a:ext>
             </a:extLst>
           </p:cNvPr>
@@ -9811,7 +9811,7 @@
           <p:cNvPr id="31" name="">
             <a:extLst xmlns:a="http://schemas.openxmlformats.org/drawingml/2006/main">
               <a:ext uri="{FF2B5EF4-FFF2-40B4-BE49-F238E27FC236}">
-                <a16:creationId xmlns:a16="http://schemas.microsoft.com/office/drawing/2014/main" id="{76C6D658-27F6-409C-8C28-035D606AE760}"/>
+                <a16:creationId xmlns:a16="http://schemas.microsoft.com/office/drawing/2014/main" id="{1EBD4A07-347E-4D4C-8BFB-199D2D186AA8}"/>
               </a:ext>
             </a:extLst>
           </p:cNvPr>
@@ -9868,7 +9868,7 @@
           <p:cNvPr id="32" name="">
             <a:extLst xmlns:a="http://schemas.openxmlformats.org/drawingml/2006/main">
               <a:ext uri="{FF2B5EF4-FFF2-40B4-BE49-F238E27FC236}">
-                <a16:creationId xmlns:a16="http://schemas.microsoft.com/office/drawing/2014/main" id="{011ED003-CB3E-4807-94EA-F1521E1A50A3}"/>
+                <a16:creationId xmlns:a16="http://schemas.microsoft.com/office/drawing/2014/main" id="{AAEEE854-D953-4E99-AB19-4A962C12CD39}"/>
               </a:ext>
             </a:extLst>
           </p:cNvPr>
@@ -9896,7 +9896,7 @@
           <p:cNvPr id="33" name="">
             <a:extLst xmlns:a="http://schemas.openxmlformats.org/drawingml/2006/main">
               <a:ext uri="{FF2B5EF4-FFF2-40B4-BE49-F238E27FC236}">
-                <a16:creationId xmlns:a16="http://schemas.microsoft.com/office/drawing/2014/main" id="{FDC1054D-9CA1-4530-B95A-40DBEFB9222E}"/>
+                <a16:creationId xmlns:a16="http://schemas.microsoft.com/office/drawing/2014/main" id="{9F9F891B-F031-4606-8C50-BA5ED8748558}"/>
               </a:ext>
             </a:extLst>
           </p:cNvPr>
@@ -9951,7 +9951,7 @@
           <p:cNvPr id="35" name="">
             <a:extLst xmlns:a="http://schemas.openxmlformats.org/drawingml/2006/main">
               <a:ext uri="{FF2B5EF4-FFF2-40B4-BE49-F238E27FC236}">
-                <a16:creationId xmlns:a16="http://schemas.microsoft.com/office/drawing/2014/main" id="{6B282AB1-27C1-4416-86E0-9A804BF812AD}"/>
+                <a16:creationId xmlns:a16="http://schemas.microsoft.com/office/drawing/2014/main" id="{AAD22E99-69E9-4470-8EA8-1B92334858BB}"/>
               </a:ext>
             </a:extLst>
           </p:cNvPr>
@@ -10008,7 +10008,7 @@
           <p:cNvPr id="36" name="">
             <a:extLst xmlns:a="http://schemas.openxmlformats.org/drawingml/2006/main">
               <a:ext uri="{FF2B5EF4-FFF2-40B4-BE49-F238E27FC236}">
-                <a16:creationId xmlns:a16="http://schemas.microsoft.com/office/drawing/2014/main" id="{80CB00C2-2B92-48AE-940B-F3C5C9A6ADD8}"/>
+                <a16:creationId xmlns:a16="http://schemas.microsoft.com/office/drawing/2014/main" id="{FB22640A-8427-456E-8AB4-E4C4399C518B}"/>
               </a:ext>
             </a:extLst>
           </p:cNvPr>
@@ -10036,7 +10036,7 @@
           <p:cNvPr id="37" name="">
             <a:extLst xmlns:a="http://schemas.openxmlformats.org/drawingml/2006/main">
               <a:ext uri="{FF2B5EF4-FFF2-40B4-BE49-F238E27FC236}">
-                <a16:creationId xmlns:a16="http://schemas.microsoft.com/office/drawing/2014/main" id="{734AC93D-A826-4EEF-8300-C4038151CDED}"/>
+                <a16:creationId xmlns:a16="http://schemas.microsoft.com/office/drawing/2014/main" id="{40A5E2BA-D21E-4B16-9F21-80E9CD55CFE9}"/>
               </a:ext>
             </a:extLst>
           </p:cNvPr>
@@ -10091,7 +10091,7 @@
           <p:cNvPr id="39" name="">
             <a:extLst xmlns:a="http://schemas.openxmlformats.org/drawingml/2006/main">
               <a:ext uri="{FF2B5EF4-FFF2-40B4-BE49-F238E27FC236}">
-                <a16:creationId xmlns:a16="http://schemas.microsoft.com/office/drawing/2014/main" id="{A597B952-8546-419B-8348-42ADB4B1D9B0}"/>
+                <a16:creationId xmlns:a16="http://schemas.microsoft.com/office/drawing/2014/main" id="{5102195F-78C7-46F5-90D6-890ECDDB4719}"/>
               </a:ext>
             </a:extLst>
           </p:cNvPr>
@@ -10148,7 +10148,7 @@
           <p:cNvPr id="40" name="">
             <a:extLst xmlns:a="http://schemas.openxmlformats.org/drawingml/2006/main">
               <a:ext uri="{FF2B5EF4-FFF2-40B4-BE49-F238E27FC236}">
-                <a16:creationId xmlns:a16="http://schemas.microsoft.com/office/drawing/2014/main" id="{0C16795F-6A4F-4782-BAB9-841804395A64}"/>
+                <a16:creationId xmlns:a16="http://schemas.microsoft.com/office/drawing/2014/main" id="{D1715060-AFA9-4A6F-A908-A7BAFD78901D}"/>
               </a:ext>
             </a:extLst>
           </p:cNvPr>
@@ -10205,7 +10205,7 @@
           <p:cNvPr id="41" name="">
             <a:extLst xmlns:a="http://schemas.openxmlformats.org/drawingml/2006/main">
               <a:ext uri="{FF2B5EF4-FFF2-40B4-BE49-F238E27FC236}">
-                <a16:creationId xmlns:a16="http://schemas.microsoft.com/office/drawing/2014/main" id="{6B598256-3FD9-4EB0-B2FF-CD5A0AAE6A6B}"/>
+                <a16:creationId xmlns:a16="http://schemas.microsoft.com/office/drawing/2014/main" id="{1185EB25-089E-452B-A2DD-7E2A79E07F6F}"/>
               </a:ext>
             </a:extLst>
           </p:cNvPr>
@@ -10262,7 +10262,7 @@
                 <a:latin typeface="Hiragino Sans GB"/>
                 <a:ea typeface="Hiragino Sans GB"/>
                 <a:cs typeface="Hiragino Sans GB"/>
-                <a:hlinkClick xmlns:r="http://schemas.openxmlformats.org/officeDocument/2006/relationships" r:id="R6e77de4e24ef4e4e"/>
+                <a:hlinkClick xmlns:r="http://schemas.openxmlformats.org/officeDocument/2006/relationships" r:id="Rbf3634bc6d784c40"/>
               </a:rPr>
               <a:t>MYA 实现与实测</a:t>
             </a:r>
@@ -10272,7 +10272,7 @@
     </p:spTree>
     <p:extLst>
       <p:ext uri="{BB962C8B-B14F-4D97-AF65-F5344CB8AC3E}">
-        <p14:creationId xmlns:p14="http://schemas.microsoft.com/office/powerpoint/2010/main" val="1502759680"/>
+        <p14:creationId xmlns:p14="http://schemas.microsoft.com/office/powerpoint/2010/main" val="1332069911"/>
       </p:ext>
     </p:extLst>
   </p:cSld>
@@ -10303,7 +10303,7 @@
           <p:cNvPr id="38" name="">
             <a:extLst xmlns:a="http://schemas.openxmlformats.org/drawingml/2006/main">
               <a:ext uri="{FF2B5EF4-FFF2-40B4-BE49-F238E27FC236}">
-                <a16:creationId xmlns:a16="http://schemas.microsoft.com/office/drawing/2014/main" id="{0588A5A6-4CA3-4489-9202-6CDA0864B7B2}"/>
+                <a16:creationId xmlns:a16="http://schemas.microsoft.com/office/drawing/2014/main" id="{BC513701-DB78-4B60-8BE4-A4A814097ADE}"/>
               </a:ext>
             </a:extLst>
           </p:cNvPr>
@@ -10360,7 +10360,7 @@
           <p:cNvPr id="2" name="">
             <a:extLst xmlns:a="http://schemas.openxmlformats.org/drawingml/2006/main">
               <a:ext uri="{FF2B5EF4-FFF2-40B4-BE49-F238E27FC236}">
-                <a16:creationId xmlns:a16="http://schemas.microsoft.com/office/drawing/2014/main" id="{1E46C697-97F5-47DD-8EF6-FE6F075D14BE}"/>
+                <a16:creationId xmlns:a16="http://schemas.microsoft.com/office/drawing/2014/main" id="{A9DDEEB4-D739-40BF-A7D9-A57EBF100542}"/>
               </a:ext>
             </a:extLst>
           </p:cNvPr>
@@ -10417,7 +10417,7 @@
           <p:cNvPr id="3" name="">
             <a:extLst xmlns:a="http://schemas.openxmlformats.org/drawingml/2006/main">
               <a:ext uri="{FF2B5EF4-FFF2-40B4-BE49-F238E27FC236}">
-                <a16:creationId xmlns:a16="http://schemas.microsoft.com/office/drawing/2014/main" id="{836D360F-C942-4186-831A-806B7DCC1B9C}"/>
+                <a16:creationId xmlns:a16="http://schemas.microsoft.com/office/drawing/2014/main" id="{C0DE9692-FEA9-4B5B-90F5-FD1635ECA43A}"/>
               </a:ext>
             </a:extLst>
           </p:cNvPr>
@@ -10474,7 +10474,7 @@
           <p:cNvPr id="4" name="">
             <a:extLst xmlns:a="http://schemas.openxmlformats.org/drawingml/2006/main">
               <a:ext uri="{FF2B5EF4-FFF2-40B4-BE49-F238E27FC236}">
-                <a16:creationId xmlns:a16="http://schemas.microsoft.com/office/drawing/2014/main" id="{30B179B7-93C0-4CB4-8E01-BAEF6A4970D0}"/>
+                <a16:creationId xmlns:a16="http://schemas.microsoft.com/office/drawing/2014/main" id="{A6322538-3B2C-4EE7-9D6C-942C130934D6}"/>
               </a:ext>
             </a:extLst>
           </p:cNvPr>
@@ -10507,7 +10507,7 @@
           <p:cNvPr id="5" name="">
             <a:extLst xmlns:a="http://schemas.openxmlformats.org/drawingml/2006/main">
               <a:ext uri="{FF2B5EF4-FFF2-40B4-BE49-F238E27FC236}">
-                <a16:creationId xmlns:a16="http://schemas.microsoft.com/office/drawing/2014/main" id="{A04E3F10-F04E-4FBC-8F19-A67942BD5E88}"/>
+                <a16:creationId xmlns:a16="http://schemas.microsoft.com/office/drawing/2014/main" id="{326C1D9E-3CD0-4BFE-A2F0-CE188A3CDB3D}"/>
               </a:ext>
             </a:extLst>
           </p:cNvPr>
@@ -10564,7 +10564,7 @@
           <p:cNvPr id="6" name="">
             <a:extLst xmlns:a="http://schemas.openxmlformats.org/drawingml/2006/main">
               <a:ext uri="{FF2B5EF4-FFF2-40B4-BE49-F238E27FC236}">
-                <a16:creationId xmlns:a16="http://schemas.microsoft.com/office/drawing/2014/main" id="{B896B958-905F-44EC-AAEB-05F3F464BFC9}"/>
+                <a16:creationId xmlns:a16="http://schemas.microsoft.com/office/drawing/2014/main" id="{0E75D63A-F4F7-4376-B943-6E7F5F363BDD}"/>
               </a:ext>
             </a:extLst>
           </p:cNvPr>
@@ -10621,7 +10621,7 @@
           <p:cNvPr id="7" name="">
             <a:extLst xmlns:a="http://schemas.openxmlformats.org/drawingml/2006/main">
               <a:ext uri="{FF2B5EF4-FFF2-40B4-BE49-F238E27FC236}">
-                <a16:creationId xmlns:a16="http://schemas.microsoft.com/office/drawing/2014/main" id="{3237950C-9C35-44D4-9373-2F41063A97A9}"/>
+                <a16:creationId xmlns:a16="http://schemas.microsoft.com/office/drawing/2014/main" id="{A286F788-9A44-49D5-B3CF-32BFBBF009D8}"/>
               </a:ext>
             </a:extLst>
           </p:cNvPr>
@@ -10654,7 +10654,7 @@
           <p:cNvPr id="8" name="">
             <a:extLst xmlns:a="http://schemas.openxmlformats.org/drawingml/2006/main">
               <a:ext uri="{FF2B5EF4-FFF2-40B4-BE49-F238E27FC236}">
-                <a16:creationId xmlns:a16="http://schemas.microsoft.com/office/drawing/2014/main" id="{64607467-7515-442B-95C1-77981B19698E}"/>
+                <a16:creationId xmlns:a16="http://schemas.microsoft.com/office/drawing/2014/main" id="{0B26722C-72F5-4737-9103-FA19CD22B83A}"/>
               </a:ext>
             </a:extLst>
           </p:cNvPr>
@@ -10711,7 +10711,7 @@
           <p:cNvPr id="9" name="">
             <a:extLst xmlns:a="http://schemas.openxmlformats.org/drawingml/2006/main">
               <a:ext uri="{FF2B5EF4-FFF2-40B4-BE49-F238E27FC236}">
-                <a16:creationId xmlns:a16="http://schemas.microsoft.com/office/drawing/2014/main" id="{7C59BC88-F480-4008-85E2-884E63FB54BD}"/>
+                <a16:creationId xmlns:a16="http://schemas.microsoft.com/office/drawing/2014/main" id="{9F17A8F4-202F-459E-9BC0-B89EA2544A18}"/>
               </a:ext>
             </a:extLst>
           </p:cNvPr>
@@ -10768,7 +10768,7 @@
           <p:cNvPr id="10" name="">
             <a:extLst xmlns:a="http://schemas.openxmlformats.org/drawingml/2006/main">
               <a:ext uri="{FF2B5EF4-FFF2-40B4-BE49-F238E27FC236}">
-                <a16:creationId xmlns:a16="http://schemas.microsoft.com/office/drawing/2014/main" id="{5D11B92F-EC9B-4C53-9C50-6D1035885D00}"/>
+                <a16:creationId xmlns:a16="http://schemas.microsoft.com/office/drawing/2014/main" id="{EADC4EB3-189F-4889-9C35-1D05492A4F4F}"/>
               </a:ext>
             </a:extLst>
           </p:cNvPr>
@@ -10801,7 +10801,7 @@
           <p:cNvPr id="11" name="">
             <a:extLst xmlns:a="http://schemas.openxmlformats.org/drawingml/2006/main">
               <a:ext uri="{FF2B5EF4-FFF2-40B4-BE49-F238E27FC236}">
-                <a16:creationId xmlns:a16="http://schemas.microsoft.com/office/drawing/2014/main" id="{17585DE6-EC2A-4A2C-86B4-7F6E9FE58613}"/>
+                <a16:creationId xmlns:a16="http://schemas.microsoft.com/office/drawing/2014/main" id="{000F7186-77FC-4CA6-9393-5DBFD371BDF4}"/>
               </a:ext>
             </a:extLst>
           </p:cNvPr>
@@ -10858,7 +10858,7 @@
           <p:cNvPr id="12" name="">
             <a:extLst xmlns:a="http://schemas.openxmlformats.org/drawingml/2006/main">
               <a:ext uri="{FF2B5EF4-FFF2-40B4-BE49-F238E27FC236}">
-                <a16:creationId xmlns:a16="http://schemas.microsoft.com/office/drawing/2014/main" id="{04A5AF6F-510C-451A-A136-26F2B13B3498}"/>
+                <a16:creationId xmlns:a16="http://schemas.microsoft.com/office/drawing/2014/main" id="{C8F47A8C-0446-4348-86F4-ECA0DC04B325}"/>
               </a:ext>
             </a:extLst>
           </p:cNvPr>
@@ -10915,7 +10915,7 @@
           <p:cNvPr id="13" name="">
             <a:extLst xmlns:a="http://schemas.openxmlformats.org/drawingml/2006/main">
               <a:ext uri="{FF2B5EF4-FFF2-40B4-BE49-F238E27FC236}">
-                <a16:creationId xmlns:a16="http://schemas.microsoft.com/office/drawing/2014/main" id="{7E782EB3-A1BC-4498-98AB-35EA11BC8B98}"/>
+                <a16:creationId xmlns:a16="http://schemas.microsoft.com/office/drawing/2014/main" id="{D0C0B6AD-85BD-4B8A-94B3-8743E537062C}"/>
               </a:ext>
             </a:extLst>
           </p:cNvPr>
@@ -10948,7 +10948,7 @@
           <p:cNvPr id="14" name="">
             <a:extLst xmlns:a="http://schemas.openxmlformats.org/drawingml/2006/main">
               <a:ext uri="{FF2B5EF4-FFF2-40B4-BE49-F238E27FC236}">
-                <a16:creationId xmlns:a16="http://schemas.microsoft.com/office/drawing/2014/main" id="{3CAE720A-5E37-4CDB-9109-5F0D0B8FB5DF}"/>
+                <a16:creationId xmlns:a16="http://schemas.microsoft.com/office/drawing/2014/main" id="{C024BB6B-BF5E-4720-8371-55885FA88D8B}"/>
               </a:ext>
             </a:extLst>
           </p:cNvPr>
@@ -11005,7 +11005,7 @@
           <p:cNvPr id="15" name="">
             <a:extLst xmlns:a="http://schemas.openxmlformats.org/drawingml/2006/main">
               <a:ext uri="{FF2B5EF4-FFF2-40B4-BE49-F238E27FC236}">
-                <a16:creationId xmlns:a16="http://schemas.microsoft.com/office/drawing/2014/main" id="{FE92FEFF-1CEB-448A-8F0E-94DDB2CE7CA9}"/>
+                <a16:creationId xmlns:a16="http://schemas.microsoft.com/office/drawing/2014/main" id="{EF020DD9-F1D4-4805-918F-047C886758E0}"/>
               </a:ext>
             </a:extLst>
           </p:cNvPr>
@@ -11062,7 +11062,7 @@
           <p:cNvPr id="16" name="">
             <a:extLst xmlns:a="http://schemas.openxmlformats.org/drawingml/2006/main">
               <a:ext uri="{FF2B5EF4-FFF2-40B4-BE49-F238E27FC236}">
-                <a16:creationId xmlns:a16="http://schemas.microsoft.com/office/drawing/2014/main" id="{29E6BC84-55E1-4EEF-BADB-FF0EB723B586}"/>
+                <a16:creationId xmlns:a16="http://schemas.microsoft.com/office/drawing/2014/main" id="{BF12D8AC-B865-46CB-AB4E-057498286CCB}"/>
               </a:ext>
             </a:extLst>
           </p:cNvPr>
@@ -11095,7 +11095,7 @@
           <p:cNvPr id="17" name="">
             <a:extLst xmlns:a="http://schemas.openxmlformats.org/drawingml/2006/main">
               <a:ext uri="{FF2B5EF4-FFF2-40B4-BE49-F238E27FC236}">
-                <a16:creationId xmlns:a16="http://schemas.microsoft.com/office/drawing/2014/main" id="{9D50AB21-E9F9-43F1-A703-C22FE9F382D3}"/>
+                <a16:creationId xmlns:a16="http://schemas.microsoft.com/office/drawing/2014/main" id="{B0991694-BB39-4436-80F4-2865AA637FCB}"/>
               </a:ext>
             </a:extLst>
           </p:cNvPr>
@@ -11152,7 +11152,7 @@
           <p:cNvPr id="18" name="">
             <a:extLst xmlns:a="http://schemas.openxmlformats.org/drawingml/2006/main">
               <a:ext uri="{FF2B5EF4-FFF2-40B4-BE49-F238E27FC236}">
-                <a16:creationId xmlns:a16="http://schemas.microsoft.com/office/drawing/2014/main" id="{4C5086DF-FA51-4811-8B76-B033B31A3112}"/>
+                <a16:creationId xmlns:a16="http://schemas.microsoft.com/office/drawing/2014/main" id="{B8C498EB-8CD9-4AE1-A968-ED9AB93442AF}"/>
               </a:ext>
             </a:extLst>
           </p:cNvPr>
@@ -11209,7 +11209,7 @@
           <p:cNvPr id="19" name="">
             <a:extLst xmlns:a="http://schemas.openxmlformats.org/drawingml/2006/main">
               <a:ext uri="{FF2B5EF4-FFF2-40B4-BE49-F238E27FC236}">
-                <a16:creationId xmlns:a16="http://schemas.microsoft.com/office/drawing/2014/main" id="{831428D1-DFE1-45C2-B537-3A67A0873BC3}"/>
+                <a16:creationId xmlns:a16="http://schemas.microsoft.com/office/drawing/2014/main" id="{44411475-2CE1-48BB-BDF4-2B522B8DF627}"/>
               </a:ext>
             </a:extLst>
           </p:cNvPr>
@@ -11237,7 +11237,7 @@
           <p:cNvPr id="20" name="">
             <a:extLst xmlns:a="http://schemas.openxmlformats.org/drawingml/2006/main">
               <a:ext uri="{FF2B5EF4-FFF2-40B4-BE49-F238E27FC236}">
-                <a16:creationId xmlns:a16="http://schemas.microsoft.com/office/drawing/2014/main" id="{565658CB-C1BF-4F17-97A7-20FB06B81411}"/>
+                <a16:creationId xmlns:a16="http://schemas.microsoft.com/office/drawing/2014/main" id="{D4C05AB4-12C0-424C-9DE7-F0D5591661CA}"/>
               </a:ext>
             </a:extLst>
           </p:cNvPr>
@@ -11292,7 +11292,7 @@
           <p:cNvPr id="22" name="">
             <a:extLst xmlns:a="http://schemas.openxmlformats.org/drawingml/2006/main">
               <a:ext uri="{FF2B5EF4-FFF2-40B4-BE49-F238E27FC236}">
-                <a16:creationId xmlns:a16="http://schemas.microsoft.com/office/drawing/2014/main" id="{2E36F7A9-FAE2-4533-A712-AD1AA1824D11}"/>
+                <a16:creationId xmlns:a16="http://schemas.microsoft.com/office/drawing/2014/main" id="{0F230FA0-64CF-46EE-9F08-D761EBDCD73B}"/>
               </a:ext>
             </a:extLst>
           </p:cNvPr>
@@ -11320,7 +11320,7 @@
           <p:cNvPr id="23" name="">
             <a:extLst xmlns:a="http://schemas.openxmlformats.org/drawingml/2006/main">
               <a:ext uri="{FF2B5EF4-FFF2-40B4-BE49-F238E27FC236}">
-                <a16:creationId xmlns:a16="http://schemas.microsoft.com/office/drawing/2014/main" id="{ECC79D35-BBE5-4A99-8597-EA9FE036FC2C}"/>
+                <a16:creationId xmlns:a16="http://schemas.microsoft.com/office/drawing/2014/main" id="{50D3DBF6-A21F-43D5-B1A8-9371908F7F0C}"/>
               </a:ext>
             </a:extLst>
           </p:cNvPr>
@@ -11375,7 +11375,7 @@
           <p:cNvPr id="25" name="">
             <a:extLst xmlns:a="http://schemas.openxmlformats.org/drawingml/2006/main">
               <a:ext uri="{FF2B5EF4-FFF2-40B4-BE49-F238E27FC236}">
-                <a16:creationId xmlns:a16="http://schemas.microsoft.com/office/drawing/2014/main" id="{55D0378F-4028-4B93-8E31-95EB908FEE00}"/>
+                <a16:creationId xmlns:a16="http://schemas.microsoft.com/office/drawing/2014/main" id="{77131F99-E8CC-4DF4-A500-AEB49934AD0C}"/>
               </a:ext>
             </a:extLst>
           </p:cNvPr>
@@ -11403,7 +11403,7 @@
           <p:cNvPr id="26" name="">
             <a:extLst xmlns:a="http://schemas.openxmlformats.org/drawingml/2006/main">
               <a:ext uri="{FF2B5EF4-FFF2-40B4-BE49-F238E27FC236}">
-                <a16:creationId xmlns:a16="http://schemas.microsoft.com/office/drawing/2014/main" id="{7ECEE9E4-800B-473E-9981-DE52741591E3}"/>
+                <a16:creationId xmlns:a16="http://schemas.microsoft.com/office/drawing/2014/main" id="{B385816A-33E4-4E94-83EE-3311E1549967}"/>
               </a:ext>
             </a:extLst>
           </p:cNvPr>
@@ -11458,7 +11458,7 @@
           <p:cNvPr id="28" name="">
             <a:extLst xmlns:a="http://schemas.openxmlformats.org/drawingml/2006/main">
               <a:ext uri="{FF2B5EF4-FFF2-40B4-BE49-F238E27FC236}">
-                <a16:creationId xmlns:a16="http://schemas.microsoft.com/office/drawing/2014/main" id="{EEE21D09-DDF5-48DC-A54C-E1D6FC93E31B}"/>
+                <a16:creationId xmlns:a16="http://schemas.microsoft.com/office/drawing/2014/main" id="{B5F5414A-1EFA-4F31-BC76-C80D0AF84096}"/>
               </a:ext>
             </a:extLst>
           </p:cNvPr>
@@ -11486,7 +11486,7 @@
           <p:cNvPr id="29" name="">
             <a:extLst xmlns:a="http://schemas.openxmlformats.org/drawingml/2006/main">
               <a:ext uri="{FF2B5EF4-FFF2-40B4-BE49-F238E27FC236}">
-                <a16:creationId xmlns:a16="http://schemas.microsoft.com/office/drawing/2014/main" id="{1AC07A21-ECFE-4015-BDBC-D6AF800643E5}"/>
+                <a16:creationId xmlns:a16="http://schemas.microsoft.com/office/drawing/2014/main" id="{421F1B22-C7FF-4E0C-BAD8-A1FAF3EF116C}"/>
               </a:ext>
             </a:extLst>
           </p:cNvPr>
@@ -11538,7 +11538,7 @@
           <p:cNvPr id="31" name="">
             <a:extLst xmlns:a="http://schemas.openxmlformats.org/drawingml/2006/main">
               <a:ext uri="{FF2B5EF4-FFF2-40B4-BE49-F238E27FC236}">
-                <a16:creationId xmlns:a16="http://schemas.microsoft.com/office/drawing/2014/main" id="{5866F48A-55CF-470C-B22C-99EC5D0F8A74}"/>
+                <a16:creationId xmlns:a16="http://schemas.microsoft.com/office/drawing/2014/main" id="{9009FF90-C0BE-4432-8F45-08A293D4C361}"/>
               </a:ext>
             </a:extLst>
           </p:cNvPr>
@@ -11566,7 +11566,7 @@
           <p:cNvPr id="32" name="">
             <a:extLst xmlns:a="http://schemas.openxmlformats.org/drawingml/2006/main">
               <a:ext uri="{FF2B5EF4-FFF2-40B4-BE49-F238E27FC236}">
-                <a16:creationId xmlns:a16="http://schemas.microsoft.com/office/drawing/2014/main" id="{93FDF591-027E-460A-87F8-5B0E56F520D3}"/>
+                <a16:creationId xmlns:a16="http://schemas.microsoft.com/office/drawing/2014/main" id="{1C14A650-B3FE-4547-86D8-B513725B59C3}"/>
               </a:ext>
             </a:extLst>
           </p:cNvPr>
@@ -11648,7 +11648,7 @@
           <p:cNvPr id="35" name="">
             <a:extLst xmlns:a="http://schemas.openxmlformats.org/drawingml/2006/main">
               <a:ext uri="{FF2B5EF4-FFF2-40B4-BE49-F238E27FC236}">
-                <a16:creationId xmlns:a16="http://schemas.microsoft.com/office/drawing/2014/main" id="{E55F57E3-C319-46CC-A0E0-0348A23F9BE6}"/>
+                <a16:creationId xmlns:a16="http://schemas.microsoft.com/office/drawing/2014/main" id="{21C123C0-E983-4052-B0E0-2E32DDC0DA21}"/>
               </a:ext>
             </a:extLst>
           </p:cNvPr>
@@ -11705,7 +11705,7 @@
           <p:cNvPr id="36" name="">
             <a:extLst xmlns:a="http://schemas.openxmlformats.org/drawingml/2006/main">
               <a:ext uri="{FF2B5EF4-FFF2-40B4-BE49-F238E27FC236}">
-                <a16:creationId xmlns:a16="http://schemas.microsoft.com/office/drawing/2014/main" id="{4C581066-E446-47D7-A462-31EB58A0A86D}"/>
+                <a16:creationId xmlns:a16="http://schemas.microsoft.com/office/drawing/2014/main" id="{8475F506-EC1C-4B85-BDFF-6C46F706A8DC}"/>
               </a:ext>
             </a:extLst>
           </p:cNvPr>
@@ -11762,7 +11762,7 @@
           <p:cNvPr id="37" name="">
             <a:extLst xmlns:a="http://schemas.openxmlformats.org/drawingml/2006/main">
               <a:ext uri="{FF2B5EF4-FFF2-40B4-BE49-F238E27FC236}">
-                <a16:creationId xmlns:a16="http://schemas.microsoft.com/office/drawing/2014/main" id="{ECED3AD3-2035-49E8-A14F-A07F9692DC29}"/>
+                <a16:creationId xmlns:a16="http://schemas.microsoft.com/office/drawing/2014/main" id="{DD20359C-D292-4A1E-A24A-C89F2736A238}"/>
               </a:ext>
             </a:extLst>
           </p:cNvPr>
@@ -11819,7 +11819,7 @@
                 <a:latin typeface="Hiragino Sans GB"/>
                 <a:ea typeface="Hiragino Sans GB"/>
                 <a:cs typeface="Hiragino Sans GB"/>
-                <a:hlinkClick xmlns:r="http://schemas.openxmlformats.org/officeDocument/2006/relationships" r:id="R55bb68c0508646a4"/>
+                <a:hlinkClick xmlns:r="http://schemas.openxmlformats.org/officeDocument/2006/relationships" r:id="R99fabd5438b74f18"/>
               </a:rPr>
               <a:t>MYA 实现与实测</a:t>
             </a:r>
@@ -11829,7 +11829,7 @@
     </p:spTree>
     <p:extLst>
       <p:ext uri="{BB962C8B-B14F-4D97-AF65-F5344CB8AC3E}">
-        <p14:creationId xmlns:p14="http://schemas.microsoft.com/office/powerpoint/2010/main" val="944766368"/>
+        <p14:creationId xmlns:p14="http://schemas.microsoft.com/office/powerpoint/2010/main" val="763577089"/>
       </p:ext>
     </p:extLst>
   </p:cSld>
@@ -11860,7 +11860,7 @@
           <p:cNvPr id="31" name="">
             <a:extLst xmlns:a="http://schemas.openxmlformats.org/drawingml/2006/main">
               <a:ext uri="{FF2B5EF4-FFF2-40B4-BE49-F238E27FC236}">
-                <a16:creationId xmlns:a16="http://schemas.microsoft.com/office/drawing/2014/main" id="{0BA4C722-F161-43F9-BF21-3CD52B61F724}"/>
+                <a16:creationId xmlns:a16="http://schemas.microsoft.com/office/drawing/2014/main" id="{D250A4D5-629E-40BC-A26D-F3780F647C7C}"/>
               </a:ext>
             </a:extLst>
           </p:cNvPr>
@@ -11917,7 +11917,7 @@
           <p:cNvPr id="2" name="">
             <a:extLst xmlns:a="http://schemas.openxmlformats.org/drawingml/2006/main">
               <a:ext uri="{FF2B5EF4-FFF2-40B4-BE49-F238E27FC236}">
-                <a16:creationId xmlns:a16="http://schemas.microsoft.com/office/drawing/2014/main" id="{C4C48760-E5AB-404B-AB43-073F71DAAA19}"/>
+                <a16:creationId xmlns:a16="http://schemas.microsoft.com/office/drawing/2014/main" id="{15712490-1ACD-4F6E-BB1E-53EC06374223}"/>
               </a:ext>
             </a:extLst>
           </p:cNvPr>
@@ -11974,7 +11974,7 @@
           <p:cNvPr id="3" name="">
             <a:extLst xmlns:a="http://schemas.openxmlformats.org/drawingml/2006/main">
               <a:ext uri="{FF2B5EF4-FFF2-40B4-BE49-F238E27FC236}">
-                <a16:creationId xmlns:a16="http://schemas.microsoft.com/office/drawing/2014/main" id="{E7B1FECA-0D80-4474-AFCF-74F3D84560BD}"/>
+                <a16:creationId xmlns:a16="http://schemas.microsoft.com/office/drawing/2014/main" id="{59A99F20-A123-4120-91FF-3570E4C855E7}"/>
               </a:ext>
             </a:extLst>
           </p:cNvPr>
@@ -12031,7 +12031,7 @@
           <p:cNvPr id="4" name="">
             <a:extLst xmlns:a="http://schemas.openxmlformats.org/drawingml/2006/main">
               <a:ext uri="{FF2B5EF4-FFF2-40B4-BE49-F238E27FC236}">
-                <a16:creationId xmlns:a16="http://schemas.microsoft.com/office/drawing/2014/main" id="{15D2FF60-2DE8-4AF5-A6DB-EA9A0D50A5D8}"/>
+                <a16:creationId xmlns:a16="http://schemas.microsoft.com/office/drawing/2014/main" id="{6E72E3A6-6C80-4F1D-9018-550BE9185FB5}"/>
               </a:ext>
             </a:extLst>
           </p:cNvPr>
@@ -12064,7 +12064,7 @@
           <p:cNvPr id="5" name="">
             <a:extLst xmlns:a="http://schemas.openxmlformats.org/drawingml/2006/main">
               <a:ext uri="{FF2B5EF4-FFF2-40B4-BE49-F238E27FC236}">
-                <a16:creationId xmlns:a16="http://schemas.microsoft.com/office/drawing/2014/main" id="{9B27AE6A-AFD5-4157-9F1E-362BB89099F5}"/>
+                <a16:creationId xmlns:a16="http://schemas.microsoft.com/office/drawing/2014/main" id="{A0C510DB-3FF9-4A48-B320-E4FFF4B93162}"/>
               </a:ext>
             </a:extLst>
           </p:cNvPr>
@@ -12121,7 +12121,7 @@
           <p:cNvPr id="6" name="">
             <a:extLst xmlns:a="http://schemas.openxmlformats.org/drawingml/2006/main">
               <a:ext uri="{FF2B5EF4-FFF2-40B4-BE49-F238E27FC236}">
-                <a16:creationId xmlns:a16="http://schemas.microsoft.com/office/drawing/2014/main" id="{9FA4805E-C758-4813-A672-CC5420352BFC}"/>
+                <a16:creationId xmlns:a16="http://schemas.microsoft.com/office/drawing/2014/main" id="{02B6E10F-3960-4D78-8B4D-EF38BC27A43C}"/>
               </a:ext>
             </a:extLst>
           </p:cNvPr>
@@ -12178,7 +12178,7 @@
           <p:cNvPr id="7" name="">
             <a:extLst xmlns:a="http://schemas.openxmlformats.org/drawingml/2006/main">
               <a:ext uri="{FF2B5EF4-FFF2-40B4-BE49-F238E27FC236}">
-                <a16:creationId xmlns:a16="http://schemas.microsoft.com/office/drawing/2014/main" id="{FD03885F-9878-46E7-83A3-ADC4A19B8144}"/>
+                <a16:creationId xmlns:a16="http://schemas.microsoft.com/office/drawing/2014/main" id="{F25EB20D-E977-4F52-8812-11E332B69C61}"/>
               </a:ext>
             </a:extLst>
           </p:cNvPr>
@@ -12211,7 +12211,7 @@
           <p:cNvPr id="8" name="">
             <a:extLst xmlns:a="http://schemas.openxmlformats.org/drawingml/2006/main">
               <a:ext uri="{FF2B5EF4-FFF2-40B4-BE49-F238E27FC236}">
-                <a16:creationId xmlns:a16="http://schemas.microsoft.com/office/drawing/2014/main" id="{891440FC-6912-4ED7-9B55-9162B2654061}"/>
+                <a16:creationId xmlns:a16="http://schemas.microsoft.com/office/drawing/2014/main" id="{3E8C9491-FF9D-42E4-8935-D78BB191CC6F}"/>
               </a:ext>
             </a:extLst>
           </p:cNvPr>
@@ -12268,7 +12268,7 @@
           <p:cNvPr id="9" name="">
             <a:extLst xmlns:a="http://schemas.openxmlformats.org/drawingml/2006/main">
               <a:ext uri="{FF2B5EF4-FFF2-40B4-BE49-F238E27FC236}">
-                <a16:creationId xmlns:a16="http://schemas.microsoft.com/office/drawing/2014/main" id="{C8CA4370-87EC-4BC4-A8EF-E29081BBE41A}"/>
+                <a16:creationId xmlns:a16="http://schemas.microsoft.com/office/drawing/2014/main" id="{65B330E8-C88B-46A0-B143-4B927056BF8A}"/>
               </a:ext>
             </a:extLst>
           </p:cNvPr>
@@ -12325,7 +12325,7 @@
           <p:cNvPr id="10" name="">
             <a:extLst xmlns:a="http://schemas.openxmlformats.org/drawingml/2006/main">
               <a:ext uri="{FF2B5EF4-FFF2-40B4-BE49-F238E27FC236}">
-                <a16:creationId xmlns:a16="http://schemas.microsoft.com/office/drawing/2014/main" id="{02D21019-8143-4EA8-99DD-7041DA4B8299}"/>
+                <a16:creationId xmlns:a16="http://schemas.microsoft.com/office/drawing/2014/main" id="{2DCA8757-4596-4B0A-9B92-C1B08693030D}"/>
               </a:ext>
             </a:extLst>
           </p:cNvPr>
@@ -12358,7 +12358,7 @@
           <p:cNvPr id="11" name="">
             <a:extLst xmlns:a="http://schemas.openxmlformats.org/drawingml/2006/main">
               <a:ext uri="{FF2B5EF4-FFF2-40B4-BE49-F238E27FC236}">
-                <a16:creationId xmlns:a16="http://schemas.microsoft.com/office/drawing/2014/main" id="{D940DBE5-EED3-4167-BE1F-743D13FEE49D}"/>
+                <a16:creationId xmlns:a16="http://schemas.microsoft.com/office/drawing/2014/main" id="{9C4C1F14-8CF5-49B0-BE15-AE11CB16AB28}"/>
               </a:ext>
             </a:extLst>
           </p:cNvPr>
@@ -12415,7 +12415,7 @@
           <p:cNvPr id="12" name="">
             <a:extLst xmlns:a="http://schemas.openxmlformats.org/drawingml/2006/main">
               <a:ext uri="{FF2B5EF4-FFF2-40B4-BE49-F238E27FC236}">
-                <a16:creationId xmlns:a16="http://schemas.microsoft.com/office/drawing/2014/main" id="{F03D8A47-46AB-4CFE-AED1-B1C318218283}"/>
+                <a16:creationId xmlns:a16="http://schemas.microsoft.com/office/drawing/2014/main" id="{66BE41D8-300C-4CFE-A3A0-E1B6BC5B68F0}"/>
               </a:ext>
             </a:extLst>
           </p:cNvPr>
@@ -12530,7 +12530,7 @@
           <p:cNvPr id="15" name="">
             <a:extLst xmlns:a="http://schemas.openxmlformats.org/drawingml/2006/main">
               <a:ext uri="{FF2B5EF4-FFF2-40B4-BE49-F238E27FC236}">
-                <a16:creationId xmlns:a16="http://schemas.microsoft.com/office/drawing/2014/main" id="{4D5F9181-FEDB-411D-8B01-9977730FBECC}"/>
+                <a16:creationId xmlns:a16="http://schemas.microsoft.com/office/drawing/2014/main" id="{029BB178-19F1-4433-B391-CC43CE93F1F7}"/>
               </a:ext>
             </a:extLst>
           </p:cNvPr>
@@ -12563,7 +12563,7 @@
           <p:cNvPr id="16" name="">
             <a:extLst xmlns:a="http://schemas.openxmlformats.org/drawingml/2006/main">
               <a:ext uri="{FF2B5EF4-FFF2-40B4-BE49-F238E27FC236}">
-                <a16:creationId xmlns:a16="http://schemas.microsoft.com/office/drawing/2014/main" id="{E0DCCDD9-6B61-406B-8A96-F2C63BCAE6D7}"/>
+                <a16:creationId xmlns:a16="http://schemas.microsoft.com/office/drawing/2014/main" id="{7D71E245-B687-4238-8386-D4C91A13F06A}"/>
               </a:ext>
             </a:extLst>
           </p:cNvPr>
@@ -12620,7 +12620,7 @@
           <p:cNvPr id="17" name="">
             <a:extLst xmlns:a="http://schemas.openxmlformats.org/drawingml/2006/main">
               <a:ext uri="{FF2B5EF4-FFF2-40B4-BE49-F238E27FC236}">
-                <a16:creationId xmlns:a16="http://schemas.microsoft.com/office/drawing/2014/main" id="{59873FE7-AB59-42A8-AF34-B012F7C38783}"/>
+                <a16:creationId xmlns:a16="http://schemas.microsoft.com/office/drawing/2014/main" id="{72AB004B-4C50-4357-BDC5-763C3C0BB634}"/>
               </a:ext>
             </a:extLst>
           </p:cNvPr>
@@ -12677,7 +12677,7 @@
           <p:cNvPr id="18" name="">
             <a:extLst xmlns:a="http://schemas.openxmlformats.org/drawingml/2006/main">
               <a:ext uri="{FF2B5EF4-FFF2-40B4-BE49-F238E27FC236}">
-                <a16:creationId xmlns:a16="http://schemas.microsoft.com/office/drawing/2014/main" id="{BD0038D2-3921-42D0-9012-A72D405FD521}"/>
+                <a16:creationId xmlns:a16="http://schemas.microsoft.com/office/drawing/2014/main" id="{F8F801AB-3FE0-4E53-B885-E876B02B0FA4}"/>
               </a:ext>
             </a:extLst>
           </p:cNvPr>
@@ -12710,7 +12710,7 @@
           <p:cNvPr id="19" name="">
             <a:extLst xmlns:a="http://schemas.openxmlformats.org/drawingml/2006/main">
               <a:ext uri="{FF2B5EF4-FFF2-40B4-BE49-F238E27FC236}">
-                <a16:creationId xmlns:a16="http://schemas.microsoft.com/office/drawing/2014/main" id="{7361F74B-3ABB-492A-9228-448D82DD620E}"/>
+                <a16:creationId xmlns:a16="http://schemas.microsoft.com/office/drawing/2014/main" id="{C877CFA3-F653-4892-AFB3-839239EEED1B}"/>
               </a:ext>
             </a:extLst>
           </p:cNvPr>
@@ -12767,7 +12767,7 @@
           <p:cNvPr id="20" name="">
             <a:extLst xmlns:a="http://schemas.openxmlformats.org/drawingml/2006/main">
               <a:ext uri="{FF2B5EF4-FFF2-40B4-BE49-F238E27FC236}">
-                <a16:creationId xmlns:a16="http://schemas.microsoft.com/office/drawing/2014/main" id="{9A7B6063-60DC-42EC-859C-01BFA5F21DB5}"/>
+                <a16:creationId xmlns:a16="http://schemas.microsoft.com/office/drawing/2014/main" id="{7BC99062-9DD9-4D20-BBBB-5A1EF1B13BBC}"/>
               </a:ext>
             </a:extLst>
           </p:cNvPr>
@@ -12824,7 +12824,7 @@
           <p:cNvPr id="21" name="">
             <a:extLst xmlns:a="http://schemas.openxmlformats.org/drawingml/2006/main">
               <a:ext uri="{FF2B5EF4-FFF2-40B4-BE49-F238E27FC236}">
-                <a16:creationId xmlns:a16="http://schemas.microsoft.com/office/drawing/2014/main" id="{FDA7DFFD-95B5-4F85-91B4-C834A8D7BA05}"/>
+                <a16:creationId xmlns:a16="http://schemas.microsoft.com/office/drawing/2014/main" id="{BB8DE261-8F7F-4FDE-B52E-95E28D4B160C}"/>
               </a:ext>
             </a:extLst>
           </p:cNvPr>
@@ -12857,7 +12857,7 @@
           <p:cNvPr id="22" name="">
             <a:extLst xmlns:a="http://schemas.openxmlformats.org/drawingml/2006/main">
               <a:ext uri="{FF2B5EF4-FFF2-40B4-BE49-F238E27FC236}">
-                <a16:creationId xmlns:a16="http://schemas.microsoft.com/office/drawing/2014/main" id="{8A6DEF10-5ABD-4E81-A3F1-ECD2E0CBC0FD}"/>
+                <a16:creationId xmlns:a16="http://schemas.microsoft.com/office/drawing/2014/main" id="{4763D159-DC3B-4DBA-8BF8-3AC963CFA6B2}"/>
               </a:ext>
             </a:extLst>
           </p:cNvPr>
@@ -12914,7 +12914,7 @@
           <p:cNvPr id="23" name="">
             <a:extLst xmlns:a="http://schemas.openxmlformats.org/drawingml/2006/main">
               <a:ext uri="{FF2B5EF4-FFF2-40B4-BE49-F238E27FC236}">
-                <a16:creationId xmlns:a16="http://schemas.microsoft.com/office/drawing/2014/main" id="{A47B8399-C7AC-4348-987B-BABB126277AC}"/>
+                <a16:creationId xmlns:a16="http://schemas.microsoft.com/office/drawing/2014/main" id="{185ABBD2-7F57-4C8D-A67F-363C5E13DFFE}"/>
               </a:ext>
             </a:extLst>
           </p:cNvPr>
@@ -13053,7 +13053,7 @@
           <p:cNvPr id="27" name="">
             <a:extLst xmlns:a="http://schemas.openxmlformats.org/drawingml/2006/main">
               <a:ext uri="{FF2B5EF4-FFF2-40B4-BE49-F238E27FC236}">
-                <a16:creationId xmlns:a16="http://schemas.microsoft.com/office/drawing/2014/main" id="{FAEBC84E-DD0C-407E-93E7-D5DEAD355262}"/>
+                <a16:creationId xmlns:a16="http://schemas.microsoft.com/office/drawing/2014/main" id="{0E8FCBAD-1E71-4746-9290-C9E45B76F86D}"/>
               </a:ext>
             </a:extLst>
           </p:cNvPr>
@@ -13110,7 +13110,7 @@
           <p:cNvPr id="28" name="">
             <a:extLst xmlns:a="http://schemas.openxmlformats.org/drawingml/2006/main">
               <a:ext uri="{FF2B5EF4-FFF2-40B4-BE49-F238E27FC236}">
-                <a16:creationId xmlns:a16="http://schemas.microsoft.com/office/drawing/2014/main" id="{2728E8A6-A9FC-45C4-A1A5-3EAEF4D6F8B0}"/>
+                <a16:creationId xmlns:a16="http://schemas.microsoft.com/office/drawing/2014/main" id="{29C14939-1ECD-430C-A917-A35CD2759044}"/>
               </a:ext>
             </a:extLst>
           </p:cNvPr>
@@ -13167,7 +13167,7 @@
           <p:cNvPr id="29" name="">
             <a:extLst xmlns:a="http://schemas.openxmlformats.org/drawingml/2006/main">
               <a:ext uri="{FF2B5EF4-FFF2-40B4-BE49-F238E27FC236}">
-                <a16:creationId xmlns:a16="http://schemas.microsoft.com/office/drawing/2014/main" id="{5DDAEF77-319D-4004-9D9D-3B997DF460C6}"/>
+                <a16:creationId xmlns:a16="http://schemas.microsoft.com/office/drawing/2014/main" id="{A6468C49-0BA8-4808-A1F4-E1AD756DF9EF}"/>
               </a:ext>
             </a:extLst>
           </p:cNvPr>
@@ -13224,7 +13224,7 @@
           <p:cNvPr id="30" name="">
             <a:extLst xmlns:a="http://schemas.openxmlformats.org/drawingml/2006/main">
               <a:ext uri="{FF2B5EF4-FFF2-40B4-BE49-F238E27FC236}">
-                <a16:creationId xmlns:a16="http://schemas.microsoft.com/office/drawing/2014/main" id="{6EA5E1E0-F72E-4ED2-8631-1B6F67C5F31A}"/>
+                <a16:creationId xmlns:a16="http://schemas.microsoft.com/office/drawing/2014/main" id="{2776A0E1-B078-43CA-99AF-A793A6E5D1F9}"/>
               </a:ext>
             </a:extLst>
           </p:cNvPr>
@@ -13281,7 +13281,7 @@
                 <a:latin typeface="Hiragino Sans GB"/>
                 <a:ea typeface="Hiragino Sans GB"/>
                 <a:cs typeface="Hiragino Sans GB"/>
-                <a:hlinkClick xmlns:r="http://schemas.openxmlformats.org/officeDocument/2006/relationships" r:id="R0d718e178bdc4579"/>
+                <a:hlinkClick xmlns:r="http://schemas.openxmlformats.org/officeDocument/2006/relationships" r:id="Rde6ae29809014767"/>
               </a:rPr>
               <a:t>MYA 实现与实测</a:t>
             </a:r>
@@ -13291,7 +13291,7 @@
     </p:spTree>
     <p:extLst>
       <p:ext uri="{BB962C8B-B14F-4D97-AF65-F5344CB8AC3E}">
-        <p14:creationId xmlns:p14="http://schemas.microsoft.com/office/powerpoint/2010/main" val="1103134527"/>
+        <p14:creationId xmlns:p14="http://schemas.microsoft.com/office/powerpoint/2010/main" val="1033655230"/>
       </p:ext>
     </p:extLst>
   </p:cSld>
@@ -13322,7 +13322,7 @@
           <p:cNvPr id="33" name="">
             <a:extLst xmlns:a="http://schemas.openxmlformats.org/drawingml/2006/main">
               <a:ext uri="{FF2B5EF4-FFF2-40B4-BE49-F238E27FC236}">
-                <a16:creationId xmlns:a16="http://schemas.microsoft.com/office/drawing/2014/main" id="{20A8DE67-EB48-42CE-99E3-2D7804209F33}"/>
+                <a16:creationId xmlns:a16="http://schemas.microsoft.com/office/drawing/2014/main" id="{88C0FA5B-06E6-4E60-BB43-C81E7F7308CE}"/>
               </a:ext>
             </a:extLst>
           </p:cNvPr>
@@ -13379,7 +13379,7 @@
           <p:cNvPr id="2" name="">
             <a:extLst xmlns:a="http://schemas.openxmlformats.org/drawingml/2006/main">
               <a:ext uri="{FF2B5EF4-FFF2-40B4-BE49-F238E27FC236}">
-                <a16:creationId xmlns:a16="http://schemas.microsoft.com/office/drawing/2014/main" id="{918D1CEF-19C1-46A6-8EB8-07C0BD346453}"/>
+                <a16:creationId xmlns:a16="http://schemas.microsoft.com/office/drawing/2014/main" id="{53139120-7C1B-484D-B984-652F0CC1DDC6}"/>
               </a:ext>
             </a:extLst>
           </p:cNvPr>
@@ -13436,7 +13436,7 @@
           <p:cNvPr id="3" name="">
             <a:extLst xmlns:a="http://schemas.openxmlformats.org/drawingml/2006/main">
               <a:ext uri="{FF2B5EF4-FFF2-40B4-BE49-F238E27FC236}">
-                <a16:creationId xmlns:a16="http://schemas.microsoft.com/office/drawing/2014/main" id="{1F33C481-9D16-4C04-9D66-2DEC5B8A4149}"/>
+                <a16:creationId xmlns:a16="http://schemas.microsoft.com/office/drawing/2014/main" id="{F8DEC1F8-FF64-458F-8DC4-6CB13AD2104B}"/>
               </a:ext>
             </a:extLst>
           </p:cNvPr>
@@ -13493,7 +13493,7 @@
           <p:cNvPr id="4" name="">
             <a:extLst xmlns:a="http://schemas.openxmlformats.org/drawingml/2006/main">
               <a:ext uri="{FF2B5EF4-FFF2-40B4-BE49-F238E27FC236}">
-                <a16:creationId xmlns:a16="http://schemas.microsoft.com/office/drawing/2014/main" id="{04C09653-1A64-48FE-BCD8-E64B6C0BC362}"/>
+                <a16:creationId xmlns:a16="http://schemas.microsoft.com/office/drawing/2014/main" id="{90EB8D19-2186-49D7-87FE-69E455A42C19}"/>
               </a:ext>
             </a:extLst>
           </p:cNvPr>
@@ -13524,7 +13524,7 @@
           <p:cNvPr id="5" name="">
             <a:extLst xmlns:a="http://schemas.openxmlformats.org/drawingml/2006/main">
               <a:ext uri="{FF2B5EF4-FFF2-40B4-BE49-F238E27FC236}">
-                <a16:creationId xmlns:a16="http://schemas.microsoft.com/office/drawing/2014/main" id="{60D9F913-D711-4F85-BB39-D3125B61AC39}"/>
+                <a16:creationId xmlns:a16="http://schemas.microsoft.com/office/drawing/2014/main" id="{3A44E70E-6111-4319-950D-ACDE075AB1EA}"/>
               </a:ext>
             </a:extLst>
           </p:cNvPr>
@@ -13581,7 +13581,7 @@
           <p:cNvPr id="6" name="">
             <a:extLst xmlns:a="http://schemas.openxmlformats.org/drawingml/2006/main">
               <a:ext uri="{FF2B5EF4-FFF2-40B4-BE49-F238E27FC236}">
-                <a16:creationId xmlns:a16="http://schemas.microsoft.com/office/drawing/2014/main" id="{645F59D2-1C6F-45BC-B641-043A3A870D72}"/>
+                <a16:creationId xmlns:a16="http://schemas.microsoft.com/office/drawing/2014/main" id="{229F306B-637C-4E14-B7A1-D4DDEC3A492C}"/>
               </a:ext>
             </a:extLst>
           </p:cNvPr>
@@ -13614,7 +13614,7 @@
           <p:cNvPr id="7" name="">
             <a:extLst xmlns:a="http://schemas.openxmlformats.org/drawingml/2006/main">
               <a:ext uri="{FF2B5EF4-FFF2-40B4-BE49-F238E27FC236}">
-                <a16:creationId xmlns:a16="http://schemas.microsoft.com/office/drawing/2014/main" id="{5C5F7C82-0C62-4056-BABF-DDB4F08F76EC}"/>
+                <a16:creationId xmlns:a16="http://schemas.microsoft.com/office/drawing/2014/main" id="{129713AD-F57C-45F7-9E1E-5F9DE3240EF6}"/>
               </a:ext>
             </a:extLst>
           </p:cNvPr>
@@ -13671,7 +13671,7 @@
           <p:cNvPr id="8" name="">
             <a:extLst xmlns:a="http://schemas.openxmlformats.org/drawingml/2006/main">
               <a:ext uri="{FF2B5EF4-FFF2-40B4-BE49-F238E27FC236}">
-                <a16:creationId xmlns:a16="http://schemas.microsoft.com/office/drawing/2014/main" id="{9E859FAA-FA83-48EE-BCC2-990D796BE7EC}"/>
+                <a16:creationId xmlns:a16="http://schemas.microsoft.com/office/drawing/2014/main" id="{F895AD5C-3124-4ED2-93A0-464A18AA46BC}"/>
               </a:ext>
             </a:extLst>
           </p:cNvPr>
@@ -13728,7 +13728,7 @@
           <p:cNvPr id="9" name="">
             <a:extLst xmlns:a="http://schemas.openxmlformats.org/drawingml/2006/main">
               <a:ext uri="{FF2B5EF4-FFF2-40B4-BE49-F238E27FC236}">
-                <a16:creationId xmlns:a16="http://schemas.microsoft.com/office/drawing/2014/main" id="{CD216AFD-E6E2-414F-AE77-E2445E912AB2}"/>
+                <a16:creationId xmlns:a16="http://schemas.microsoft.com/office/drawing/2014/main" id="{FF2017D9-600D-4977-A6DF-D4DEB33A333D}"/>
               </a:ext>
             </a:extLst>
           </p:cNvPr>
@@ -13761,7 +13761,7 @@
           <p:cNvPr id="10" name="">
             <a:extLst xmlns:a="http://schemas.openxmlformats.org/drawingml/2006/main">
               <a:ext uri="{FF2B5EF4-FFF2-40B4-BE49-F238E27FC236}">
-                <a16:creationId xmlns:a16="http://schemas.microsoft.com/office/drawing/2014/main" id="{2EB7E9C3-184F-457F-837C-F4760D4FF30E}"/>
+                <a16:creationId xmlns:a16="http://schemas.microsoft.com/office/drawing/2014/main" id="{7CCBAD2D-8C9B-4CCE-B3DF-AF1088DE78A4}"/>
               </a:ext>
             </a:extLst>
           </p:cNvPr>
@@ -13818,7 +13818,7 @@
           <p:cNvPr id="11" name="">
             <a:extLst xmlns:a="http://schemas.openxmlformats.org/drawingml/2006/main">
               <a:ext uri="{FF2B5EF4-FFF2-40B4-BE49-F238E27FC236}">
-                <a16:creationId xmlns:a16="http://schemas.microsoft.com/office/drawing/2014/main" id="{7625D217-8BED-4648-B385-569732081EAD}"/>
+                <a16:creationId xmlns:a16="http://schemas.microsoft.com/office/drawing/2014/main" id="{273F9DD0-9D22-419A-A1D5-B45F53DAD814}"/>
               </a:ext>
             </a:extLst>
           </p:cNvPr>
@@ -13875,7 +13875,7 @@
           <p:cNvPr id="12" name="">
             <a:extLst xmlns:a="http://schemas.openxmlformats.org/drawingml/2006/main">
               <a:ext uri="{FF2B5EF4-FFF2-40B4-BE49-F238E27FC236}">
-                <a16:creationId xmlns:a16="http://schemas.microsoft.com/office/drawing/2014/main" id="{328EFF37-357C-43A9-9772-09F4A509B6E4}"/>
+                <a16:creationId xmlns:a16="http://schemas.microsoft.com/office/drawing/2014/main" id="{7AA2FB2E-A8EA-43C0-8DB8-85DA08B18566}"/>
               </a:ext>
             </a:extLst>
           </p:cNvPr>
@@ -13908,7 +13908,7 @@
           <p:cNvPr id="13" name="">
             <a:extLst xmlns:a="http://schemas.openxmlformats.org/drawingml/2006/main">
               <a:ext uri="{FF2B5EF4-FFF2-40B4-BE49-F238E27FC236}">
-                <a16:creationId xmlns:a16="http://schemas.microsoft.com/office/drawing/2014/main" id="{794AC047-3C33-4840-8402-7BB85908AC75}"/>
+                <a16:creationId xmlns:a16="http://schemas.microsoft.com/office/drawing/2014/main" id="{5DC1576D-1662-4EBC-801C-72FE56EEF9BE}"/>
               </a:ext>
             </a:extLst>
           </p:cNvPr>
@@ -13965,7 +13965,7 @@
           <p:cNvPr id="14" name="">
             <a:extLst xmlns:a="http://schemas.openxmlformats.org/drawingml/2006/main">
               <a:ext uri="{FF2B5EF4-FFF2-40B4-BE49-F238E27FC236}">
-                <a16:creationId xmlns:a16="http://schemas.microsoft.com/office/drawing/2014/main" id="{7445FF5E-1E42-4E23-9631-3DA7DAF08F78}"/>
+                <a16:creationId xmlns:a16="http://schemas.microsoft.com/office/drawing/2014/main" id="{04176777-F9D8-4458-82C9-75DF897EC84B}"/>
               </a:ext>
             </a:extLst>
           </p:cNvPr>
@@ -14022,7 +14022,7 @@
           <p:cNvPr id="15" name="">
             <a:extLst xmlns:a="http://schemas.openxmlformats.org/drawingml/2006/main">
               <a:ext uri="{FF2B5EF4-FFF2-40B4-BE49-F238E27FC236}">
-                <a16:creationId xmlns:a16="http://schemas.microsoft.com/office/drawing/2014/main" id="{7AC16FF6-C37A-4EA3-9C31-5F6A1676983F}"/>
+                <a16:creationId xmlns:a16="http://schemas.microsoft.com/office/drawing/2014/main" id="{D3E2767E-FE3F-41CA-9F12-9BAEFC011B8F}"/>
               </a:ext>
             </a:extLst>
           </p:cNvPr>
@@ -14055,7 +14055,7 @@
           <p:cNvPr id="16" name="">
             <a:extLst xmlns:a="http://schemas.openxmlformats.org/drawingml/2006/main">
               <a:ext uri="{FF2B5EF4-FFF2-40B4-BE49-F238E27FC236}">
-                <a16:creationId xmlns:a16="http://schemas.microsoft.com/office/drawing/2014/main" id="{A62E7FCF-8FFC-42B9-A91A-014F8486792C}"/>
+                <a16:creationId xmlns:a16="http://schemas.microsoft.com/office/drawing/2014/main" id="{9DA7FAB4-5008-4F02-8959-ED4903F5F5AF}"/>
               </a:ext>
             </a:extLst>
           </p:cNvPr>
@@ -14112,7 +14112,7 @@
           <p:cNvPr id="17" name="">
             <a:extLst xmlns:a="http://schemas.openxmlformats.org/drawingml/2006/main">
               <a:ext uri="{FF2B5EF4-FFF2-40B4-BE49-F238E27FC236}">
-                <a16:creationId xmlns:a16="http://schemas.microsoft.com/office/drawing/2014/main" id="{65AD806C-4DF8-42C6-A0ED-5B7B7FBE1E64}"/>
+                <a16:creationId xmlns:a16="http://schemas.microsoft.com/office/drawing/2014/main" id="{80F5388D-475A-4F48-BCEC-1288F2EC71EA}"/>
               </a:ext>
             </a:extLst>
           </p:cNvPr>
@@ -14192,7 +14192,7 @@
           <p:cNvPr id="18" name="">
             <a:extLst xmlns:a="http://schemas.openxmlformats.org/drawingml/2006/main">
               <a:ext uri="{FF2B5EF4-FFF2-40B4-BE49-F238E27FC236}">
-                <a16:creationId xmlns:a16="http://schemas.microsoft.com/office/drawing/2014/main" id="{C5E28B2F-413A-4234-B394-D476A42EF67A}"/>
+                <a16:creationId xmlns:a16="http://schemas.microsoft.com/office/drawing/2014/main" id="{1EF59CED-3413-4183-9AC4-3D8ED759C0EA}"/>
               </a:ext>
             </a:extLst>
           </p:cNvPr>
@@ -14225,7 +14225,7 @@
           <p:cNvPr id="19" name="">
             <a:extLst xmlns:a="http://schemas.openxmlformats.org/drawingml/2006/main">
               <a:ext uri="{FF2B5EF4-FFF2-40B4-BE49-F238E27FC236}">
-                <a16:creationId xmlns:a16="http://schemas.microsoft.com/office/drawing/2014/main" id="{1F955828-EE6F-4CC5-8F97-221A72B57EC5}"/>
+                <a16:creationId xmlns:a16="http://schemas.microsoft.com/office/drawing/2014/main" id="{B8A45EF7-6690-42D8-9EB7-7A68AE10C27F}"/>
               </a:ext>
             </a:extLst>
           </p:cNvPr>
@@ -14282,7 +14282,7 @@
           <p:cNvPr id="20" name="">
             <a:extLst xmlns:a="http://schemas.openxmlformats.org/drawingml/2006/main">
               <a:ext uri="{FF2B5EF4-FFF2-40B4-BE49-F238E27FC236}">
-                <a16:creationId xmlns:a16="http://schemas.microsoft.com/office/drawing/2014/main" id="{40930FC3-FE6F-4332-91A7-9859877D48A6}"/>
+                <a16:creationId xmlns:a16="http://schemas.microsoft.com/office/drawing/2014/main" id="{B2533180-02DC-489A-83F9-EF0D2E8EED59}"/>
               </a:ext>
             </a:extLst>
           </p:cNvPr>
@@ -14339,7 +14339,7 @@
           <p:cNvPr id="21" name="">
             <a:extLst xmlns:a="http://schemas.openxmlformats.org/drawingml/2006/main">
               <a:ext uri="{FF2B5EF4-FFF2-40B4-BE49-F238E27FC236}">
-                <a16:creationId xmlns:a16="http://schemas.microsoft.com/office/drawing/2014/main" id="{062A311D-BA98-4BEF-ADD8-6C776697A418}"/>
+                <a16:creationId xmlns:a16="http://schemas.microsoft.com/office/drawing/2014/main" id="{C71E59AB-B4DC-41FF-B0C3-C3FC0F318CD2}"/>
               </a:ext>
             </a:extLst>
           </p:cNvPr>
@@ -14372,7 +14372,7 @@
           <p:cNvPr id="22" name="">
             <a:extLst xmlns:a="http://schemas.openxmlformats.org/drawingml/2006/main">
               <a:ext uri="{FF2B5EF4-FFF2-40B4-BE49-F238E27FC236}">
-                <a16:creationId xmlns:a16="http://schemas.microsoft.com/office/drawing/2014/main" id="{86A5E468-F029-415C-83F7-1241F0603566}"/>
+                <a16:creationId xmlns:a16="http://schemas.microsoft.com/office/drawing/2014/main" id="{BBE1D758-9B04-4E43-B4CE-BB9DA321F17D}"/>
               </a:ext>
             </a:extLst>
           </p:cNvPr>
@@ -14429,7 +14429,7 @@
           <p:cNvPr id="23" name="">
             <a:extLst xmlns:a="http://schemas.openxmlformats.org/drawingml/2006/main">
               <a:ext uri="{FF2B5EF4-FFF2-40B4-BE49-F238E27FC236}">
-                <a16:creationId xmlns:a16="http://schemas.microsoft.com/office/drawing/2014/main" id="{9D927AE9-013E-4A8A-BBB8-72C9D10D10A2}"/>
+                <a16:creationId xmlns:a16="http://schemas.microsoft.com/office/drawing/2014/main" id="{84336CFD-5661-494C-8115-05E8BC9182F0}"/>
               </a:ext>
             </a:extLst>
           </p:cNvPr>
@@ -14621,7 +14621,7 @@
           <p:cNvPr id="29" name="">
             <a:extLst xmlns:a="http://schemas.openxmlformats.org/drawingml/2006/main">
               <a:ext uri="{FF2B5EF4-FFF2-40B4-BE49-F238E27FC236}">
-                <a16:creationId xmlns:a16="http://schemas.microsoft.com/office/drawing/2014/main" id="{2369470B-E426-4F56-86E5-313A6E2D4122}"/>
+                <a16:creationId xmlns:a16="http://schemas.microsoft.com/office/drawing/2014/main" id="{4A681BC8-4475-4831-A77D-BB2A971CCE92}"/>
               </a:ext>
             </a:extLst>
           </p:cNvPr>
@@ -14678,7 +14678,7 @@
           <p:cNvPr id="30" name="">
             <a:extLst xmlns:a="http://schemas.openxmlformats.org/drawingml/2006/main">
               <a:ext uri="{FF2B5EF4-FFF2-40B4-BE49-F238E27FC236}">
-                <a16:creationId xmlns:a16="http://schemas.microsoft.com/office/drawing/2014/main" id="{7240FC2F-3C08-4B5F-8509-62F57BDB0C4E}"/>
+                <a16:creationId xmlns:a16="http://schemas.microsoft.com/office/drawing/2014/main" id="{23B3ACF7-767A-47E9-AB8C-E97D1FE8C2A5}"/>
               </a:ext>
             </a:extLst>
           </p:cNvPr>
@@ -14735,7 +14735,7 @@
           <p:cNvPr id="31" name="">
             <a:extLst xmlns:a="http://schemas.openxmlformats.org/drawingml/2006/main">
               <a:ext uri="{FF2B5EF4-FFF2-40B4-BE49-F238E27FC236}">
-                <a16:creationId xmlns:a16="http://schemas.microsoft.com/office/drawing/2014/main" id="{69FAF4A5-27F5-43E6-9045-F976830A8C51}"/>
+                <a16:creationId xmlns:a16="http://schemas.microsoft.com/office/drawing/2014/main" id="{6673EB10-8BE1-49EC-A3EA-4E14DD1BAB5E}"/>
               </a:ext>
             </a:extLst>
           </p:cNvPr>
@@ -14792,7 +14792,7 @@
           <p:cNvPr id="32" name="">
             <a:extLst xmlns:a="http://schemas.openxmlformats.org/drawingml/2006/main">
               <a:ext uri="{FF2B5EF4-FFF2-40B4-BE49-F238E27FC236}">
-                <a16:creationId xmlns:a16="http://schemas.microsoft.com/office/drawing/2014/main" id="{12A30E28-F44F-4BCA-BECF-2C05DD94631C}"/>
+                <a16:creationId xmlns:a16="http://schemas.microsoft.com/office/drawing/2014/main" id="{763413D5-5AF2-4E32-A885-D64F8D20970F}"/>
               </a:ext>
             </a:extLst>
           </p:cNvPr>
@@ -14849,7 +14849,7 @@
                 <a:latin typeface="Hiragino Sans GB"/>
                 <a:ea typeface="Hiragino Sans GB"/>
                 <a:cs typeface="Hiragino Sans GB"/>
-                <a:hlinkClick xmlns:r="http://schemas.openxmlformats.org/officeDocument/2006/relationships" r:id="R8c779aea05ff4a04"/>
+                <a:hlinkClick xmlns:r="http://schemas.openxmlformats.org/officeDocument/2006/relationships" r:id="Rd28d30a6fd7c47a3"/>
               </a:rPr>
               <a:t>MYA 实现与实测</a:t>
             </a:r>
@@ -14859,7 +14859,7 @@
     </p:spTree>
     <p:extLst>
       <p:ext uri="{BB962C8B-B14F-4D97-AF65-F5344CB8AC3E}">
-        <p14:creationId xmlns:p14="http://schemas.microsoft.com/office/powerpoint/2010/main" val="549789106"/>
+        <p14:creationId xmlns:p14="http://schemas.microsoft.com/office/powerpoint/2010/main" val="1676083175"/>
       </p:ext>
     </p:extLst>
   </p:cSld>

</xml_diff>